<commit_message>
Add pnpm scripts that start the embedding service alone or together with the app
</commit_message>
<xml_diff>
--- a/docs/presentation/presentation.pptx
+++ b/docs/presentation/presentation.pptx
@@ -165,7 +165,7 @@
     </p:spTree>
     <p:extLst>
       <p:ext uri="{BB962C8B-B14F-4D97-AF65-F5344CB8AC3E}">
-        <p14:creationId xmlns:p14="http://schemas.microsoft.com/office/powerpoint/2010/main" val="2310618442"/>
+        <p14:creationId xmlns:p14="http://schemas.microsoft.com/office/powerpoint/2010/main" val="1692480302"/>
       </p:ext>
     </p:extLst>
   </p:cSld>
@@ -1488,7 +1488,7 @@
         </p:nvSpPr>
         <p:spPr>
           <a:xfrm>
-            <a:off x="640080" y="3337560"/>
+            <a:off x="640080" y="3108960"/>
             <a:ext cx="7498080" cy="548640"/>
           </a:xfrm>
           <a:prstGeom prst="rect">
@@ -1527,8 +1527,8 @@
         </p:nvSpPr>
         <p:spPr>
           <a:xfrm>
-            <a:off x="640080" y="4069080"/>
-            <a:ext cx="6949440" cy="1234440"/>
+            <a:off x="640080" y="3794760"/>
+            <a:ext cx="6949440" cy="1508760"/>
           </a:xfrm>
           <a:prstGeom prst="rect">
             <a:avLst/>
@@ -1555,7 +1555,7 @@
                 <a:ea typeface="Atkinson Hyperlegible Next" pitchFamily="34" charset="-122"/>
                 <a:cs typeface="Atkinson Hyperlegible Next" pitchFamily="34" charset="-120"/>
               </a:rPr>
-              <a:t>A working prototype of the digital core that ROPS Kraków plans for the Małopolska Social Innovation Hub: a need described in plain Polish becomes a route to proven solutions, knowledge, people and funding, not a list of links or a chatbot answer.</a:t>
+              <a:t>A working prototype of the digital core that ROPS Kraków plans for the Małopolska Social Innovation Hub: a need that a resident, a social worker, an NGO leader or a municipal official describes in plain Polish becomes a route to proven solutions, knowledge, people and funding, not a list of links or a chatbot answer.</a:t>
             </a:r>
             <a:endParaRPr lang="en-US" sz="1600" dirty="0"/>
           </a:p>
@@ -2383,11 +2383,11 @@
         <p:spPr>
           <a:xfrm>
             <a:off x="640080" y="1965960"/>
-            <a:ext cx="3017520" cy="2331720"/>
+            <a:ext cx="3017520" cy="3474720"/>
           </a:xfrm>
           <a:prstGeom prst="roundRect">
             <a:avLst>
-              <a:gd name="adj" fmla="val 4706"/>
+              <a:gd name="adj" fmla="val 3636"/>
             </a:avLst>
           </a:prstGeom>
           <a:solidFill>
@@ -2410,7 +2410,7 @@
         <p:spPr>
           <a:xfrm>
             <a:off x="841248" y="2103120"/>
-            <a:ext cx="2615184" cy="2103120"/>
+            <a:ext cx="2615184" cy="2514600"/>
           </a:xfrm>
           <a:prstGeom prst="rect">
             <a:avLst/>
@@ -2437,7 +2437,7 @@
                 <a:ea typeface="Atkinson Hyperlegible Next" pitchFamily="34" charset="-122"/>
                 <a:cs typeface="Atkinson Hyperlegible Next" pitchFamily="34" charset="-120"/>
               </a:rPr>
-              <a:t>„Coraz więcej samotnych seniorów w naszej gminie. Nie ma domu dziennego pobytu ani klubu seniora… Gmina ma świetlicę wiejską wolną trzy dni w tygodniu.”</a:t>
+              <a:t>„Coraz więcej samotnych seniorów w naszej gminie. Nie ma domu dziennego pobytu ani klubu seniora, a sąsiedzi zgłaszają, że starsze osoby nie wychodzą z domu i nie mają z kim porozmawiać. Gmina ma świetlicę wiejską wolną trzy dni w tygodniu.”</a:t>
             </a:r>
             <a:endParaRPr lang="en-US" sz="1300" dirty="0"/>
           </a:p>
@@ -2460,7 +2460,7 @@
                 <a:ea typeface="Atkinson Hyperlegible Next" pitchFamily="34" charset="-122"/>
                 <a:cs typeface="Atkinson Hyperlegible Next" pitchFamily="34" charset="-120"/>
               </a:rPr>
-              <a:t>More and more lonely seniors, no day centre or seniors' club, a village hall free three days a week.</a:t>
+              <a:t>Lonely seniors stay at home, no day centre or club; a village hall is free three days a week.</a:t>
             </a:r>
             <a:endParaRPr lang="en-US" sz="1300" dirty="0"/>
           </a:p>
@@ -2474,8 +2474,8 @@
         </p:nvSpPr>
         <p:spPr>
           <a:xfrm>
-            <a:off x="640080" y="4480560"/>
-            <a:ext cx="3017520" cy="594360"/>
+            <a:off x="841248" y="4800600"/>
+            <a:ext cx="2615184" cy="594360"/>
           </a:xfrm>
           <a:prstGeom prst="rect">
             <a:avLst/>
@@ -2513,7 +2513,7 @@
                 <a:ea typeface="Atkinson Hyperlegible Next" pitchFamily="34" charset="-122"/>
                 <a:cs typeface="Atkinson Hyperlegible Next" pitchFamily="34" charset="-120"/>
               </a:rPr>
-              <a:t>gmina Laskowa, rural</a:t>
+              <a:t>gmina Laskowa</a:t>
             </a:r>
             <a:endParaRPr lang="en-US" sz="1300" dirty="0"/>
           </a:p>
@@ -2558,7 +2558,7 @@
         </p:nvSpPr>
         <p:spPr>
           <a:xfrm>
-            <a:off x="2971800" y="5394960"/>
+            <a:off x="2971800" y="5705856"/>
             <a:ext cx="685800" cy="384048"/>
           </a:xfrm>
           <a:prstGeom prst="rightArrow">
@@ -2583,8 +2583,8 @@
         </p:nvSpPr>
         <p:spPr>
           <a:xfrm>
-            <a:off x="640080" y="5239512"/>
-            <a:ext cx="2194560" cy="685800"/>
+            <a:off x="640080" y="5577840"/>
+            <a:ext cx="2194560" cy="640080"/>
           </a:xfrm>
           <a:prstGeom prst="rect">
             <a:avLst/>
@@ -4336,7 +4336,7 @@
                           <a:ea typeface="Atkinson Hyperlegible Next" pitchFamily="34" charset="-122"/>
                           <a:cs typeface="Atkinson Hyperlegible Next" pitchFamily="34" charset="-120"/>
                         </a:rPr>
-                        <a:t>It says so: below a fit of 45 of 100 there is no route, and the need goes to the needs bank and the incubator</a:t>
+                        <a:t>It says so: below a fit of 45 out of 100 there is no route, and the need goes to the needs bank and the incubator</a:t>
                       </a:r>
                       <a:endParaRPr lang="en-US" sz="1200" dirty="0">
                         <a:latin typeface="Atkinson Hyperlegible Next" charset="0"/>
@@ -6091,7 +6091,7 @@
                 <a:ea typeface="Atkinson Hyperlegible Next" pitchFamily="34" charset="-122"/>
                 <a:cs typeface="Atkinson Hyperlegible Next" pitchFamily="34" charset="-120"/>
               </a:rPr>
-              <a:t>The reverse: where is it needed?</a:t>
+              <a:t>Where it is needed most</a:t>
             </a:r>
             <a:endParaRPr lang="en-US" sz="1400" dirty="0"/>
           </a:p>
@@ -6403,7 +6403,7 @@
                 <a:ea typeface="Atkinson Hyperlegible Next" pitchFamily="34" charset="-122"/>
                 <a:cs typeface="Atkinson Hyperlegible Next" pitchFamily="34" charset="-120"/>
               </a:rPr>
-              <a:t>Retrieval is one step of five, and the gate comes first. The model selects and explains; people decide.</a:t>
+              <a:t>The screening gate comes first. The model selects and explains; people decide.</a:t>
             </a:r>
             <a:endParaRPr lang="en-US" sz="3200" dirty="0"/>
           </a:p>

</xml_diff>

<commit_message>
Added demo data for admin console
</commit_message>
<xml_diff>
--- a/docs/presentation/presentation.pptx
+++ b/docs/presentation/presentation.pptx
@@ -158,7 +158,7 @@
     </p:spTree>
     <p:extLst>
       <p:ext uri="{BB962C8B-B14F-4D97-AF65-F5344CB8AC3E}">
-        <p14:creationId xmlns:p14="http://schemas.microsoft.com/office/powerpoint/2010/main" val="935328210"/>
+        <p14:creationId xmlns:p14="http://schemas.microsoft.com/office/powerpoint/2010/main" val="1245963314"/>
       </p:ext>
     </p:extLst>
   </p:cSld>
@@ -1506,7 +1506,7 @@
                 <a:ea typeface="Atkinson Hyperlegible Next" pitchFamily="34" charset="-122"/>
                 <a:cs typeface="Atkinson Hyperlegible Next" pitchFamily="34" charset="-120"/>
               </a:rPr>
-              <a:t>Droga, nie katalog.</a:t>
+              <a:t>Więcej niż katalog – wsparcie w działaniu</a:t>
             </a:r>
             <a:endParaRPr lang="en-US" sz="2800" dirty="0"/>
           </a:p>

</xml_diff>

<commit_message>
Count the demonstration data always in the trends and the questions of the ROPS panel, without a filter for real entries
</commit_message>
<xml_diff>
--- a/docs/presentation/presentation.pptx
+++ b/docs/presentation/presentation.pptx
@@ -158,7 +158,7 @@
     </p:spTree>
     <p:extLst>
       <p:ext uri="{BB962C8B-B14F-4D97-AF65-F5344CB8AC3E}">
-        <p14:creationId xmlns:p14="http://schemas.microsoft.com/office/powerpoint/2010/main" val="1245963314"/>
+        <p14:creationId xmlns:p14="http://schemas.microsoft.com/office/powerpoint/2010/main" val="486834089"/>
       </p:ext>
     </p:extLst>
   </p:cSld>
@@ -913,7 +913,7 @@
           <a:p>
             <a:r>
               <a:rPr lang="en-US" dirty="0"/>
-              <a:t>Zadanie wymaga koncepcji, a nie tylko oprogramowania. To, co widzieliście, działa dziś: droga dla osób zgłaszających potrzeby, a obok fiszka pomysłu, tester innowacji, rozmowy z ROPS i mentorami oraz tablica partnerstw. Z siedmiu modułów wyzwania pięć działa w całości, a dwa – częściowo. Zasobnik wiedzy celowo nie jest kolejnym katalogiem, bo partner wyraźnie tego nie chce: wiedza jest częścią drogi, z linkami do wszystkich materiałów, dokumentów i filmów. Każdy wpis trafia do panelu ROPS: decyzję podejmuje pracownik, a system odnotowuje ją z jego nazwiskiem; autor pomysłu widzi odpowiedź na stronie swojej fiszki. Plan rozwoju dotyczy ludzi wokół narzędzia: trzech ról, które mogą pełnić trzy osoby albo jedna – opiekun kategorii, czyli osoba kontaktowa w każdej drodze, redaktor katalogu i koordynator banku potrzeb. Usługa domknie trzy cykle: potrzeba staje się wdrożeniem; potrzeba bez rozwiązania staje się tematem naboru do inkubatora, a potem nową innowacją; sprawdzona innowacja trafia tam, gdzie jest potrzebna. Utrzymanie jest tanie: jeden serwer 4 GB dla aplikacji i polskiego modelu wyszukiwania to 24 dolary miesięcznie na AWS Lightsail; w wersji docelowej PostgreSQL z pgvector na RDS, około 30 dolarów miesięcznie (prototyp zapisuje wpisy w jednym pliku). Jedno zapytanie do Bielika przez Hugging Face to około pięciu tysięcy tokenów po 40 centów za milion, czyli jedna piąta centa; cała droga to cztery zapytania, łącznie poniżej jednego centa.</a:t>
+              <a:t>Zadanie wymaga koncepcji, a nie tylko oprogramowania. To, co widzieliście, jest już zaimplementowane: droga dla osób zgłaszających potrzeby, a obok fiszka pomysłu, tester innowacji, rozmowy z ROPS i mentorami oraz tablica partnerstw. Z siedmiu modułów wyzwania pięć jest zaimplementowanych w całości, a dwa – częściowo. Zasobnik wiedzy celowo nie jest kolejnym katalogiem, bo partner wyraźnie tego nie chce: wiedza jest częścią drogi, z linkami do wszystkich materiałów, dokumentów i filmów. Każdy wpis trafia do panelu ROPS: decyzję podejmuje pracownik, a system odnotowuje ją z jego nazwiskiem; autor pomysłu widzi odpowiedź na stronie swojej fiszki. Plan rozwoju dotyczy ludzi wokół narzędzia: trzech ról, które mogą pełnić trzy osoby albo jedna – opiekun kategorii, czyli osoba kontaktowa w każdej drodze, redaktor katalogu i koordynator banku potrzeb. Usługa domknie trzy cykle: potrzeba staje się wdrożeniem; potrzeba bez rozwiązania staje się tematem naboru do inkubatora, a potem nową innowacją; sprawdzona innowacja trafia tam, gdzie jest potrzebna. Utrzymanie jest tanie: jeden serwer 4 GB dla aplikacji i polskiego modelu wyszukiwania to 24 dolary miesięcznie na AWS Lightsail; w wersji docelowej PostgreSQL z pgvector na RDS, około 30 dolarów miesięcznie (prototyp zapisuje wpisy w jednym pliku). Jedno zapytanie do Bielika przez Hugging Face to około pięciu tysięcy tokenów po 40 centów za milion, czyli jedna piąta centa; cała droga to cztery zapytania, łącznie poniżej jednego centa.</a:t>
             </a:r>
           </a:p>
         </p:txBody>
@@ -1750,7 +1750,7 @@
         <p:spPr>
           <a:xfrm>
             <a:off x="640080" y="329184"/>
-            <a:ext cx="786384" cy="237744"/>
+            <a:ext cx="1298448" cy="237744"/>
           </a:xfrm>
           <a:prstGeom prst="roundRect">
             <a:avLst>
@@ -1777,7 +1777,7 @@
         <p:spPr>
           <a:xfrm>
             <a:off x="640080" y="329184"/>
-            <a:ext cx="786384" cy="237744"/>
+            <a:ext cx="1298448" cy="237744"/>
           </a:xfrm>
           <a:prstGeom prst="rect">
             <a:avLst/>
@@ -1801,7 +1801,7 @@
                 <a:ea typeface="Atkinson Hyperlegible Next" pitchFamily="34" charset="-122"/>
                 <a:cs typeface="Atkinson Hyperlegible Next" pitchFamily="34" charset="-120"/>
               </a:rPr>
-              <a:t>działa</a:t>
+              <a:t>zaimplementowane</a:t>
             </a:r>
             <a:endParaRPr lang="en-US" sz="1000" dirty="0"/>
           </a:p>
@@ -1815,8 +1815,8 @@
         </p:nvSpPr>
         <p:spPr>
           <a:xfrm>
-            <a:off x="1563624" y="329184"/>
-            <a:ext cx="9987991" cy="237744"/>
+            <a:off x="2075688" y="329184"/>
+            <a:ext cx="9475927" cy="237744"/>
           </a:xfrm>
           <a:prstGeom prst="rect">
             <a:avLst/>
@@ -1879,7 +1879,7 @@
                 <a:ea typeface="Atkinson Hyperlegible Next" pitchFamily="34" charset="-122"/>
                 <a:cs typeface="Atkinson Hyperlegible Next" pitchFamily="34" charset="-120"/>
               </a:rPr>
-              <a:t>Opisz potrzebę, poznaj drogę</a:t>
+              <a:t>Opisz potrzebę, wybierz rozwiązanie</a:t>
             </a:r>
             <a:endParaRPr lang="en-US" sz="3200" dirty="0"/>
           </a:p>
@@ -3041,7 +3041,7 @@
         <p:spPr>
           <a:xfrm>
             <a:off x="640080" y="329184"/>
-            <a:ext cx="786384" cy="237744"/>
+            <a:ext cx="1298448" cy="237744"/>
           </a:xfrm>
           <a:prstGeom prst="roundRect">
             <a:avLst>
@@ -3068,7 +3068,7 @@
         <p:spPr>
           <a:xfrm>
             <a:off x="640080" y="329184"/>
-            <a:ext cx="786384" cy="237744"/>
+            <a:ext cx="1298448" cy="237744"/>
           </a:xfrm>
           <a:prstGeom prst="rect">
             <a:avLst/>
@@ -3092,7 +3092,7 @@
                 <a:ea typeface="Atkinson Hyperlegible Next" pitchFamily="34" charset="-122"/>
                 <a:cs typeface="Atkinson Hyperlegible Next" pitchFamily="34" charset="-120"/>
               </a:rPr>
-              <a:t>działa</a:t>
+              <a:t>zaimplementowane</a:t>
             </a:r>
             <a:endParaRPr lang="en-US" sz="1000" dirty="0"/>
           </a:p>
@@ -3106,8 +3106,8 @@
         </p:nvSpPr>
         <p:spPr>
           <a:xfrm>
-            <a:off x="1563624" y="329184"/>
-            <a:ext cx="9987991" cy="237744"/>
+            <a:off x="2075688" y="329184"/>
+            <a:ext cx="9475927" cy="237744"/>
           </a:xfrm>
           <a:prstGeom prst="rect">
             <a:avLst/>
@@ -5120,7 +5120,7 @@
         <p:spPr>
           <a:xfrm>
             <a:off x="640080" y="329184"/>
-            <a:ext cx="786384" cy="237744"/>
+            <a:ext cx="1298448" cy="237744"/>
           </a:xfrm>
           <a:prstGeom prst="roundRect">
             <a:avLst>
@@ -5147,7 +5147,7 @@
         <p:spPr>
           <a:xfrm>
             <a:off x="640080" y="329184"/>
-            <a:ext cx="786384" cy="237744"/>
+            <a:ext cx="1298448" cy="237744"/>
           </a:xfrm>
           <a:prstGeom prst="rect">
             <a:avLst/>
@@ -5171,7 +5171,7 @@
                 <a:ea typeface="Atkinson Hyperlegible Next" pitchFamily="34" charset="-122"/>
                 <a:cs typeface="Atkinson Hyperlegible Next" pitchFamily="34" charset="-120"/>
               </a:rPr>
-              <a:t>działa</a:t>
+              <a:t>zaimplementowane</a:t>
             </a:r>
             <a:endParaRPr lang="en-US" sz="1000" dirty="0"/>
           </a:p>
@@ -5185,8 +5185,8 @@
         </p:nvSpPr>
         <p:spPr>
           <a:xfrm>
-            <a:off x="1563624" y="329184"/>
-            <a:ext cx="9987991" cy="237744"/>
+            <a:off x="2075688" y="329184"/>
+            <a:ext cx="9475927" cy="237744"/>
           </a:xfrm>
           <a:prstGeom prst="rect">
             <a:avLst/>
@@ -6131,7 +6131,7 @@
         <p:spPr>
           <a:xfrm>
             <a:off x="640080" y="329184"/>
-            <a:ext cx="786384" cy="237744"/>
+            <a:ext cx="1298448" cy="237744"/>
           </a:xfrm>
           <a:prstGeom prst="roundRect">
             <a:avLst>
@@ -6158,7 +6158,7 @@
         <p:spPr>
           <a:xfrm>
             <a:off x="640080" y="329184"/>
-            <a:ext cx="786384" cy="237744"/>
+            <a:ext cx="1298448" cy="237744"/>
           </a:xfrm>
           <a:prstGeom prst="rect">
             <a:avLst/>
@@ -6182,7 +6182,7 @@
                 <a:ea typeface="Atkinson Hyperlegible Next" pitchFamily="34" charset="-122"/>
                 <a:cs typeface="Atkinson Hyperlegible Next" pitchFamily="34" charset="-120"/>
               </a:rPr>
-              <a:t>działa</a:t>
+              <a:t>zaimplementowane</a:t>
             </a:r>
             <a:endParaRPr lang="en-US" sz="1000" dirty="0"/>
           </a:p>
@@ -6196,8 +6196,8 @@
         </p:nvSpPr>
         <p:spPr>
           <a:xfrm>
-            <a:off x="1563624" y="329184"/>
-            <a:ext cx="9987991" cy="237744"/>
+            <a:off x="2075688" y="329184"/>
+            <a:ext cx="9475927" cy="237744"/>
           </a:xfrm>
           <a:prstGeom prst="rect">
             <a:avLst/>
@@ -7142,7 +7142,7 @@
         <p:spPr>
           <a:xfrm>
             <a:off x="640080" y="329184"/>
-            <a:ext cx="786384" cy="237744"/>
+            <a:ext cx="1298448" cy="237744"/>
           </a:xfrm>
           <a:prstGeom prst="roundRect">
             <a:avLst>
@@ -7169,7 +7169,7 @@
         <p:spPr>
           <a:xfrm>
             <a:off x="640080" y="329184"/>
-            <a:ext cx="786384" cy="237744"/>
+            <a:ext cx="1298448" cy="237744"/>
           </a:xfrm>
           <a:prstGeom prst="rect">
             <a:avLst/>
@@ -7193,7 +7193,7 @@
                 <a:ea typeface="Atkinson Hyperlegible Next" pitchFamily="34" charset="-122"/>
                 <a:cs typeface="Atkinson Hyperlegible Next" pitchFamily="34" charset="-120"/>
               </a:rPr>
-              <a:t>działa</a:t>
+              <a:t>zaimplementowane</a:t>
             </a:r>
             <a:endParaRPr lang="en-US" sz="1000" dirty="0"/>
           </a:p>
@@ -7207,8 +7207,8 @@
         </p:nvSpPr>
         <p:spPr>
           <a:xfrm>
-            <a:off x="1563624" y="329184"/>
-            <a:ext cx="9987991" cy="237744"/>
+            <a:off x="2075688" y="329184"/>
+            <a:ext cx="9475927" cy="237744"/>
           </a:xfrm>
           <a:prstGeom prst="rect">
             <a:avLst/>
@@ -9498,7 +9498,7 @@
                 <a:ea typeface="Atkinson Hyperlegible Next" pitchFamily="34" charset="-122"/>
                 <a:cs typeface="Atkinson Hyperlegible Next" pitchFamily="34" charset="-120"/>
               </a:rPr>
-              <a:t>Działa dziś. Usługa ROPS może ruszyć od poniedziałku</a:t>
+              <a:t>Zaimplementowane. Usługa ROPS – od poniedziałku</a:t>
             </a:r>
             <a:endParaRPr lang="en-US" sz="3200" dirty="0"/>
           </a:p>
@@ -9625,53 +9625,14 @@
       </p:sp>
       <p:sp>
         <p:nvSpPr>
-          <p:cNvPr id="5" name="Text 3"/>
-          <p:cNvSpPr txBox="1"/>
-          <p:nvPr/>
-        </p:nvSpPr>
-        <p:spPr>
-          <a:xfrm>
-            <a:off x="749808" y="1993392"/>
-            <a:ext cx="457200" cy="219456"/>
-          </a:xfrm>
-          <a:prstGeom prst="rect">
-            <a:avLst/>
-          </a:prstGeom>
-          <a:noFill/>
-          <a:ln/>
-        </p:spPr>
-        <p:txBody>
-          <a:bodyPr wrap="square" lIns="0" tIns="0" rIns="0" bIns="0" rtlCol="0" anchor="ctr"/>
-          <a:lstStyle/>
-          <a:p>
-            <a:pPr marL="0" indent="0">
-              <a:buNone/>
-            </a:pPr>
-            <a:r>
-              <a:rPr lang="en-US" sz="1200" b="1" dirty="0">
-                <a:solidFill>
-                  <a:srgbClr val="1A4B8C"/>
-                </a:solidFill>
-                <a:latin typeface="Atkinson Hyperlegible Next" pitchFamily="34" charset="0"/>
-                <a:ea typeface="Atkinson Hyperlegible Next" pitchFamily="34" charset="-122"/>
-                <a:cs typeface="Atkinson Hyperlegible Next" pitchFamily="34" charset="-120"/>
-              </a:rPr>
-              <a:t>I</a:t>
-            </a:r>
-            <a:endParaRPr lang="en-US" sz="1200" dirty="0"/>
-          </a:p>
-        </p:txBody>
-      </p:sp>
-      <p:sp>
-        <p:nvSpPr>
-          <p:cNvPr id="6" name="Shape 4"/>
+          <p:cNvPr id="5" name="Shape 3"/>
           <p:cNvSpPr/>
           <p:nvPr/>
         </p:nvSpPr>
         <p:spPr>
           <a:xfrm>
-            <a:off x="1263570" y="1993392"/>
-            <a:ext cx="749808" cy="219456"/>
+            <a:off x="731520" y="1993392"/>
+            <a:ext cx="1281858" cy="219456"/>
           </a:xfrm>
           <a:prstGeom prst="roundRect">
             <a:avLst>
@@ -9691,14 +9652,53 @@
       </p:sp>
       <p:sp>
         <p:nvSpPr>
+          <p:cNvPr id="6" name="Text 4"/>
+          <p:cNvSpPr txBox="1"/>
+          <p:nvPr/>
+        </p:nvSpPr>
+        <p:spPr>
+          <a:xfrm>
+            <a:off x="731520" y="1993392"/>
+            <a:ext cx="1281858" cy="219456"/>
+          </a:xfrm>
+          <a:prstGeom prst="rect">
+            <a:avLst/>
+          </a:prstGeom>
+          <a:noFill/>
+          <a:ln/>
+        </p:spPr>
+        <p:txBody>
+          <a:bodyPr wrap="square" lIns="0" tIns="0" rIns="0" bIns="0" rtlCol="0" anchor="ctr"/>
+          <a:lstStyle/>
+          <a:p>
+            <a:pPr marL="0" indent="0" algn="ctr">
+              <a:buNone/>
+            </a:pPr>
+            <a:r>
+              <a:rPr lang="en-US" sz="900" b="1" dirty="0">
+                <a:solidFill>
+                  <a:srgbClr val="FFFFFF"/>
+                </a:solidFill>
+                <a:latin typeface="Atkinson Hyperlegible Next" pitchFamily="34" charset="0"/>
+                <a:ea typeface="Atkinson Hyperlegible Next" pitchFamily="34" charset="-122"/>
+                <a:cs typeface="Atkinson Hyperlegible Next" pitchFamily="34" charset="-120"/>
+              </a:rPr>
+              <a:t>zaimplementowane</a:t>
+            </a:r>
+            <a:endParaRPr lang="en-US" sz="900" dirty="0"/>
+          </a:p>
+        </p:txBody>
+      </p:sp>
+      <p:sp>
+        <p:nvSpPr>
           <p:cNvPr id="7" name="Text 5"/>
           <p:cNvSpPr txBox="1"/>
           <p:nvPr/>
         </p:nvSpPr>
         <p:spPr>
           <a:xfrm>
-            <a:off x="1263570" y="1993392"/>
-            <a:ext cx="749808" cy="219456"/>
+            <a:off x="749808" y="2286000"/>
+            <a:ext cx="1245282" cy="859536"/>
           </a:xfrm>
           <a:prstGeom prst="rect">
             <a:avLst/>
@@ -9707,51 +9707,23 @@
           <a:ln/>
         </p:spPr>
         <p:txBody>
-          <a:bodyPr wrap="square" lIns="0" tIns="0" rIns="0" bIns="0" rtlCol="0" anchor="ctr"/>
-          <a:lstStyle/>
-          <a:p>
-            <a:pPr marL="0" indent="0" algn="ctr">
-              <a:buNone/>
-            </a:pPr>
-            <a:r>
-              <a:rPr lang="en-US" sz="900" b="1" dirty="0">
-                <a:solidFill>
-                  <a:srgbClr val="FFFFFF"/>
-                </a:solidFill>
-                <a:latin typeface="Atkinson Hyperlegible Next" pitchFamily="34" charset="0"/>
-                <a:ea typeface="Atkinson Hyperlegible Next" pitchFamily="34" charset="-122"/>
-                <a:cs typeface="Atkinson Hyperlegible Next" pitchFamily="34" charset="-120"/>
-              </a:rPr>
-              <a:t>działa</a:t>
-            </a:r>
-            <a:endParaRPr lang="en-US" sz="900" dirty="0"/>
-          </a:p>
-        </p:txBody>
-      </p:sp>
-      <p:sp>
-        <p:nvSpPr>
-          <p:cNvPr id="8" name="Text 6"/>
-          <p:cNvSpPr txBox="1"/>
-          <p:nvPr/>
-        </p:nvSpPr>
-        <p:spPr>
-          <a:xfrm>
-            <a:off x="749808" y="2286000"/>
-            <a:ext cx="1245282" cy="859536"/>
-          </a:xfrm>
-          <a:prstGeom prst="rect">
-            <a:avLst/>
-          </a:prstGeom>
-          <a:noFill/>
-          <a:ln/>
-        </p:spPr>
-        <p:txBody>
           <a:bodyPr wrap="square" lIns="0" tIns="0" rIns="0" bIns="0" rtlCol="0" anchor="t"/>
           <a:lstStyle/>
           <a:p>
             <a:pPr marL="0" indent="0">
               <a:buNone/>
             </a:pPr>
+            <a:r>
+              <a:rPr lang="en-US" sz="1150" b="1" dirty="0">
+                <a:solidFill>
+                  <a:srgbClr val="1A4B8C"/>
+                </a:solidFill>
+                <a:latin typeface="Atkinson Hyperlegible Next" pitchFamily="34" charset="0"/>
+                <a:ea typeface="Atkinson Hyperlegible Next" pitchFamily="34" charset="-122"/>
+                <a:cs typeface="Atkinson Hyperlegible Next" pitchFamily="34" charset="-120"/>
+              </a:rPr>
+              <a:t>I  </a:t>
+            </a:r>
             <a:r>
               <a:rPr lang="en-US" sz="1150" b="1" dirty="0">
                 <a:solidFill>
@@ -9789,7 +9761,7 @@
       </p:sp>
       <p:sp>
         <p:nvSpPr>
-          <p:cNvPr id="9" name="Shape 7"/>
+          <p:cNvPr id="8" name="Shape 6"/>
           <p:cNvSpPr/>
           <p:nvPr/>
         </p:nvSpPr>
@@ -9816,53 +9788,14 @@
       </p:sp>
       <p:sp>
         <p:nvSpPr>
-          <p:cNvPr id="10" name="Text 8"/>
-          <p:cNvSpPr txBox="1"/>
-          <p:nvPr/>
-        </p:nvSpPr>
-        <p:spPr>
-          <a:xfrm>
-            <a:off x="2324274" y="1993392"/>
-            <a:ext cx="457200" cy="219456"/>
-          </a:xfrm>
-          <a:prstGeom prst="rect">
-            <a:avLst/>
-          </a:prstGeom>
-          <a:noFill/>
-          <a:ln/>
-        </p:spPr>
-        <p:txBody>
-          <a:bodyPr wrap="square" lIns="0" tIns="0" rIns="0" bIns="0" rtlCol="0" anchor="ctr"/>
-          <a:lstStyle/>
-          <a:p>
-            <a:pPr marL="0" indent="0">
-              <a:buNone/>
-            </a:pPr>
-            <a:r>
-              <a:rPr lang="en-US" sz="1200" b="1" dirty="0">
-                <a:solidFill>
-                  <a:srgbClr val="1A4B8C"/>
-                </a:solidFill>
-                <a:latin typeface="Atkinson Hyperlegible Next" pitchFamily="34" charset="0"/>
-                <a:ea typeface="Atkinson Hyperlegible Next" pitchFamily="34" charset="-122"/>
-                <a:cs typeface="Atkinson Hyperlegible Next" pitchFamily="34" charset="-120"/>
-              </a:rPr>
-              <a:t>II</a:t>
-            </a:r>
-            <a:endParaRPr lang="en-US" sz="1200" dirty="0"/>
-          </a:p>
-        </p:txBody>
-      </p:sp>
-      <p:sp>
-        <p:nvSpPr>
-          <p:cNvPr id="11" name="Shape 9"/>
+          <p:cNvPr id="9" name="Shape 7"/>
           <p:cNvSpPr/>
           <p:nvPr/>
         </p:nvSpPr>
         <p:spPr>
           <a:xfrm>
-            <a:off x="2838036" y="1993392"/>
-            <a:ext cx="749808" cy="219456"/>
+            <a:off x="2305986" y="1993392"/>
+            <a:ext cx="1281858" cy="219456"/>
           </a:xfrm>
           <a:prstGeom prst="roundRect">
             <a:avLst>
@@ -9882,14 +9815,14 @@
       </p:sp>
       <p:sp>
         <p:nvSpPr>
-          <p:cNvPr id="12" name="Text 10"/>
+          <p:cNvPr id="10" name="Text 8"/>
           <p:cNvSpPr txBox="1"/>
           <p:nvPr/>
         </p:nvSpPr>
         <p:spPr>
           <a:xfrm>
-            <a:off x="2838036" y="1993392"/>
-            <a:ext cx="749808" cy="219456"/>
+            <a:off x="2305986" y="1993392"/>
+            <a:ext cx="1281858" cy="219456"/>
           </a:xfrm>
           <a:prstGeom prst="rect">
             <a:avLst/>
@@ -9913,7 +9846,7 @@
                 <a:ea typeface="Atkinson Hyperlegible Next" pitchFamily="34" charset="-122"/>
                 <a:cs typeface="Atkinson Hyperlegible Next" pitchFamily="34" charset="-120"/>
               </a:rPr>
-              <a:t>działa</a:t>
+              <a:t>zaimplementowane</a:t>
             </a:r>
             <a:endParaRPr lang="en-US" sz="900" dirty="0"/>
           </a:p>
@@ -9921,7 +9854,7 @@
       </p:sp>
       <p:sp>
         <p:nvSpPr>
-          <p:cNvPr id="13" name="Text 11"/>
+          <p:cNvPr id="11" name="Text 9"/>
           <p:cNvSpPr txBox="1"/>
           <p:nvPr/>
         </p:nvSpPr>
@@ -9943,6 +9876,17 @@
             <a:pPr marL="0" indent="0">
               <a:buNone/>
             </a:pPr>
+            <a:r>
+              <a:rPr lang="en-US" sz="1150" b="1" dirty="0">
+                <a:solidFill>
+                  <a:srgbClr val="1A4B8C"/>
+                </a:solidFill>
+                <a:latin typeface="Atkinson Hyperlegible Next" pitchFamily="34" charset="0"/>
+                <a:ea typeface="Atkinson Hyperlegible Next" pitchFamily="34" charset="-122"/>
+                <a:cs typeface="Atkinson Hyperlegible Next" pitchFamily="34" charset="-120"/>
+              </a:rPr>
+              <a:t>II  </a:t>
+            </a:r>
             <a:r>
               <a:rPr lang="en-US" sz="1150" b="1" dirty="0">
                 <a:solidFill>
@@ -9980,7 +9924,7 @@
       </p:sp>
       <p:sp>
         <p:nvSpPr>
-          <p:cNvPr id="14" name="Shape 12"/>
+          <p:cNvPr id="12" name="Shape 10"/>
           <p:cNvSpPr/>
           <p:nvPr/>
         </p:nvSpPr>
@@ -10007,53 +9951,14 @@
       </p:sp>
       <p:sp>
         <p:nvSpPr>
-          <p:cNvPr id="15" name="Text 13"/>
-          <p:cNvSpPr txBox="1"/>
-          <p:nvPr/>
-        </p:nvSpPr>
-        <p:spPr>
-          <a:xfrm>
-            <a:off x="3898740" y="1993392"/>
-            <a:ext cx="457200" cy="219456"/>
-          </a:xfrm>
-          <a:prstGeom prst="rect">
-            <a:avLst/>
-          </a:prstGeom>
-          <a:noFill/>
-          <a:ln/>
-        </p:spPr>
-        <p:txBody>
-          <a:bodyPr wrap="square" lIns="0" tIns="0" rIns="0" bIns="0" rtlCol="0" anchor="ctr"/>
-          <a:lstStyle/>
-          <a:p>
-            <a:pPr marL="0" indent="0">
-              <a:buNone/>
-            </a:pPr>
-            <a:r>
-              <a:rPr lang="en-US" sz="1200" b="1" dirty="0">
-                <a:solidFill>
-                  <a:srgbClr val="1A4B8C"/>
-                </a:solidFill>
-                <a:latin typeface="Atkinson Hyperlegible Next" pitchFamily="34" charset="0"/>
-                <a:ea typeface="Atkinson Hyperlegible Next" pitchFamily="34" charset="-122"/>
-                <a:cs typeface="Atkinson Hyperlegible Next" pitchFamily="34" charset="-120"/>
-              </a:rPr>
-              <a:t>III</a:t>
-            </a:r>
-            <a:endParaRPr lang="en-US" sz="1200" dirty="0"/>
-          </a:p>
-        </p:txBody>
-      </p:sp>
-      <p:sp>
-        <p:nvSpPr>
-          <p:cNvPr id="16" name="Shape 14"/>
+          <p:cNvPr id="13" name="Shape 11"/>
           <p:cNvSpPr/>
           <p:nvPr/>
         </p:nvSpPr>
         <p:spPr>
           <a:xfrm>
-            <a:off x="4412503" y="1993392"/>
-            <a:ext cx="749808" cy="219456"/>
+            <a:off x="3880452" y="1993392"/>
+            <a:ext cx="1281858" cy="219456"/>
           </a:xfrm>
           <a:prstGeom prst="roundRect">
             <a:avLst>
@@ -10073,14 +9978,14 @@
       </p:sp>
       <p:sp>
         <p:nvSpPr>
-          <p:cNvPr id="17" name="Text 15"/>
+          <p:cNvPr id="14" name="Text 12"/>
           <p:cNvSpPr txBox="1"/>
           <p:nvPr/>
         </p:nvSpPr>
         <p:spPr>
           <a:xfrm>
-            <a:off x="4412503" y="1993392"/>
-            <a:ext cx="749808" cy="219456"/>
+            <a:off x="3880452" y="1993392"/>
+            <a:ext cx="1281858" cy="219456"/>
           </a:xfrm>
           <a:prstGeom prst="rect">
             <a:avLst/>
@@ -10112,7 +10017,7 @@
       </p:sp>
       <p:sp>
         <p:nvSpPr>
-          <p:cNvPr id="18" name="Text 16"/>
+          <p:cNvPr id="15" name="Text 13"/>
           <p:cNvSpPr txBox="1"/>
           <p:nvPr/>
         </p:nvSpPr>
@@ -10134,6 +10039,17 @@
             <a:pPr marL="0" indent="0">
               <a:buNone/>
             </a:pPr>
+            <a:r>
+              <a:rPr lang="en-US" sz="1150" b="1" dirty="0">
+                <a:solidFill>
+                  <a:srgbClr val="1A4B8C"/>
+                </a:solidFill>
+                <a:latin typeface="Atkinson Hyperlegible Next" pitchFamily="34" charset="0"/>
+                <a:ea typeface="Atkinson Hyperlegible Next" pitchFamily="34" charset="-122"/>
+                <a:cs typeface="Atkinson Hyperlegible Next" pitchFamily="34" charset="-120"/>
+              </a:rPr>
+              <a:t>III  </a:t>
+            </a:r>
             <a:r>
               <a:rPr lang="en-US" sz="1150" b="1" dirty="0">
                 <a:solidFill>
@@ -10171,7 +10087,7 @@
       </p:sp>
       <p:sp>
         <p:nvSpPr>
-          <p:cNvPr id="19" name="Shape 17"/>
+          <p:cNvPr id="16" name="Shape 14"/>
           <p:cNvSpPr/>
           <p:nvPr/>
         </p:nvSpPr>
@@ -10198,53 +10114,14 @@
       </p:sp>
       <p:sp>
         <p:nvSpPr>
-          <p:cNvPr id="20" name="Text 18"/>
-          <p:cNvSpPr txBox="1"/>
-          <p:nvPr/>
-        </p:nvSpPr>
-        <p:spPr>
-          <a:xfrm>
-            <a:off x="5473207" y="1993392"/>
-            <a:ext cx="457200" cy="219456"/>
-          </a:xfrm>
-          <a:prstGeom prst="rect">
-            <a:avLst/>
-          </a:prstGeom>
-          <a:noFill/>
-          <a:ln/>
-        </p:spPr>
-        <p:txBody>
-          <a:bodyPr wrap="square" lIns="0" tIns="0" rIns="0" bIns="0" rtlCol="0" anchor="ctr"/>
-          <a:lstStyle/>
-          <a:p>
-            <a:pPr marL="0" indent="0">
-              <a:buNone/>
-            </a:pPr>
-            <a:r>
-              <a:rPr lang="en-US" sz="1200" b="1" dirty="0">
-                <a:solidFill>
-                  <a:srgbClr val="1A4B8C"/>
-                </a:solidFill>
-                <a:latin typeface="Atkinson Hyperlegible Next" pitchFamily="34" charset="0"/>
-                <a:ea typeface="Atkinson Hyperlegible Next" pitchFamily="34" charset="-122"/>
-                <a:cs typeface="Atkinson Hyperlegible Next" pitchFamily="34" charset="-120"/>
-              </a:rPr>
-              <a:t>IV</a:t>
-            </a:r>
-            <a:endParaRPr lang="en-US" sz="1200" dirty="0"/>
-          </a:p>
-        </p:txBody>
-      </p:sp>
-      <p:sp>
-        <p:nvSpPr>
-          <p:cNvPr id="21" name="Shape 19"/>
+          <p:cNvPr id="17" name="Shape 15"/>
           <p:cNvSpPr/>
           <p:nvPr/>
         </p:nvSpPr>
         <p:spPr>
           <a:xfrm>
-            <a:off x="5986969" y="1993392"/>
-            <a:ext cx="749808" cy="219456"/>
+            <a:off x="5454919" y="1993392"/>
+            <a:ext cx="1281858" cy="219456"/>
           </a:xfrm>
           <a:prstGeom prst="roundRect">
             <a:avLst>
@@ -10264,14 +10141,14 @@
       </p:sp>
       <p:sp>
         <p:nvSpPr>
-          <p:cNvPr id="22" name="Text 20"/>
+          <p:cNvPr id="18" name="Text 16"/>
           <p:cNvSpPr txBox="1"/>
           <p:nvPr/>
         </p:nvSpPr>
         <p:spPr>
           <a:xfrm>
-            <a:off x="5986969" y="1993392"/>
-            <a:ext cx="749808" cy="219456"/>
+            <a:off x="5454919" y="1993392"/>
+            <a:ext cx="1281858" cy="219456"/>
           </a:xfrm>
           <a:prstGeom prst="rect">
             <a:avLst/>
@@ -10295,7 +10172,7 @@
                 <a:ea typeface="Atkinson Hyperlegible Next" pitchFamily="34" charset="-122"/>
                 <a:cs typeface="Atkinson Hyperlegible Next" pitchFamily="34" charset="-120"/>
               </a:rPr>
-              <a:t>działa</a:t>
+              <a:t>zaimplementowane</a:t>
             </a:r>
             <a:endParaRPr lang="en-US" sz="900" dirty="0"/>
           </a:p>
@@ -10303,7 +10180,7 @@
       </p:sp>
       <p:sp>
         <p:nvSpPr>
-          <p:cNvPr id="23" name="Text 21"/>
+          <p:cNvPr id="19" name="Text 17"/>
           <p:cNvSpPr txBox="1"/>
           <p:nvPr/>
         </p:nvSpPr>
@@ -10325,6 +10202,17 @@
             <a:pPr marL="0" indent="0">
               <a:buNone/>
             </a:pPr>
+            <a:r>
+              <a:rPr lang="en-US" sz="1150" b="1" dirty="0">
+                <a:solidFill>
+                  <a:srgbClr val="1A4B8C"/>
+                </a:solidFill>
+                <a:latin typeface="Atkinson Hyperlegible Next" pitchFamily="34" charset="0"/>
+                <a:ea typeface="Atkinson Hyperlegible Next" pitchFamily="34" charset="-122"/>
+                <a:cs typeface="Atkinson Hyperlegible Next" pitchFamily="34" charset="-120"/>
+              </a:rPr>
+              <a:t>IV  </a:t>
+            </a:r>
             <a:r>
               <a:rPr lang="en-US" sz="1150" b="1" dirty="0">
                 <a:solidFill>
@@ -10362,7 +10250,7 @@
       </p:sp>
       <p:sp>
         <p:nvSpPr>
-          <p:cNvPr id="24" name="Shape 22"/>
+          <p:cNvPr id="20" name="Shape 18"/>
           <p:cNvSpPr/>
           <p:nvPr/>
         </p:nvSpPr>
@@ -10389,53 +10277,14 @@
       </p:sp>
       <p:sp>
         <p:nvSpPr>
-          <p:cNvPr id="25" name="Text 23"/>
-          <p:cNvSpPr txBox="1"/>
-          <p:nvPr/>
-        </p:nvSpPr>
-        <p:spPr>
-          <a:xfrm>
-            <a:off x="7047673" y="1993392"/>
-            <a:ext cx="457200" cy="219456"/>
-          </a:xfrm>
-          <a:prstGeom prst="rect">
-            <a:avLst/>
-          </a:prstGeom>
-          <a:noFill/>
-          <a:ln/>
-        </p:spPr>
-        <p:txBody>
-          <a:bodyPr wrap="square" lIns="0" tIns="0" rIns="0" bIns="0" rtlCol="0" anchor="ctr"/>
-          <a:lstStyle/>
-          <a:p>
-            <a:pPr marL="0" indent="0">
-              <a:buNone/>
-            </a:pPr>
-            <a:r>
-              <a:rPr lang="en-US" sz="1200" b="1" dirty="0">
-                <a:solidFill>
-                  <a:srgbClr val="1A4B8C"/>
-                </a:solidFill>
-                <a:latin typeface="Atkinson Hyperlegible Next" pitchFamily="34" charset="0"/>
-                <a:ea typeface="Atkinson Hyperlegible Next" pitchFamily="34" charset="-122"/>
-                <a:cs typeface="Atkinson Hyperlegible Next" pitchFamily="34" charset="-120"/>
-              </a:rPr>
-              <a:t>V</a:t>
-            </a:r>
-            <a:endParaRPr lang="en-US" sz="1200" dirty="0"/>
-          </a:p>
-        </p:txBody>
-      </p:sp>
-      <p:sp>
-        <p:nvSpPr>
-          <p:cNvPr id="26" name="Shape 24"/>
+          <p:cNvPr id="21" name="Shape 19"/>
           <p:cNvSpPr/>
           <p:nvPr/>
         </p:nvSpPr>
         <p:spPr>
           <a:xfrm>
-            <a:off x="7561435" y="1993392"/>
-            <a:ext cx="749808" cy="219456"/>
+            <a:off x="7029385" y="1993392"/>
+            <a:ext cx="1281858" cy="219456"/>
           </a:xfrm>
           <a:prstGeom prst="roundRect">
             <a:avLst>
@@ -10455,14 +10304,14 @@
       </p:sp>
       <p:sp>
         <p:nvSpPr>
-          <p:cNvPr id="27" name="Text 25"/>
+          <p:cNvPr id="22" name="Text 20"/>
           <p:cNvSpPr txBox="1"/>
           <p:nvPr/>
         </p:nvSpPr>
         <p:spPr>
           <a:xfrm>
-            <a:off x="7561435" y="1993392"/>
-            <a:ext cx="749808" cy="219456"/>
+            <a:off x="7029385" y="1993392"/>
+            <a:ext cx="1281858" cy="219456"/>
           </a:xfrm>
           <a:prstGeom prst="rect">
             <a:avLst/>
@@ -10486,7 +10335,7 @@
                 <a:ea typeface="Atkinson Hyperlegible Next" pitchFamily="34" charset="-122"/>
                 <a:cs typeface="Atkinson Hyperlegible Next" pitchFamily="34" charset="-120"/>
               </a:rPr>
-              <a:t>działa</a:t>
+              <a:t>zaimplementowane</a:t>
             </a:r>
             <a:endParaRPr lang="en-US" sz="900" dirty="0"/>
           </a:p>
@@ -10494,7 +10343,7 @@
       </p:sp>
       <p:sp>
         <p:nvSpPr>
-          <p:cNvPr id="28" name="Text 26"/>
+          <p:cNvPr id="23" name="Text 21"/>
           <p:cNvSpPr txBox="1"/>
           <p:nvPr/>
         </p:nvSpPr>
@@ -10516,6 +10365,17 @@
             <a:pPr marL="0" indent="0">
               <a:buNone/>
             </a:pPr>
+            <a:r>
+              <a:rPr lang="en-US" sz="1150" b="1" dirty="0">
+                <a:solidFill>
+                  <a:srgbClr val="1A4B8C"/>
+                </a:solidFill>
+                <a:latin typeface="Atkinson Hyperlegible Next" pitchFamily="34" charset="0"/>
+                <a:ea typeface="Atkinson Hyperlegible Next" pitchFamily="34" charset="-122"/>
+                <a:cs typeface="Atkinson Hyperlegible Next" pitchFamily="34" charset="-120"/>
+              </a:rPr>
+              <a:t>V  </a:t>
+            </a:r>
             <a:r>
               <a:rPr lang="en-US" sz="1150" b="1" dirty="0">
                 <a:solidFill>
@@ -10553,7 +10413,7 @@
       </p:sp>
       <p:sp>
         <p:nvSpPr>
-          <p:cNvPr id="29" name="Shape 27"/>
+          <p:cNvPr id="24" name="Shape 22"/>
           <p:cNvSpPr/>
           <p:nvPr/>
         </p:nvSpPr>
@@ -10580,53 +10440,14 @@
       </p:sp>
       <p:sp>
         <p:nvSpPr>
-          <p:cNvPr id="30" name="Text 28"/>
-          <p:cNvSpPr txBox="1"/>
-          <p:nvPr/>
-        </p:nvSpPr>
-        <p:spPr>
-          <a:xfrm>
-            <a:off x="8622139" y="1993392"/>
-            <a:ext cx="457200" cy="219456"/>
-          </a:xfrm>
-          <a:prstGeom prst="rect">
-            <a:avLst/>
-          </a:prstGeom>
-          <a:noFill/>
-          <a:ln/>
-        </p:spPr>
-        <p:txBody>
-          <a:bodyPr wrap="square" lIns="0" tIns="0" rIns="0" bIns="0" rtlCol="0" anchor="ctr"/>
-          <a:lstStyle/>
-          <a:p>
-            <a:pPr marL="0" indent="0">
-              <a:buNone/>
-            </a:pPr>
-            <a:r>
-              <a:rPr lang="en-US" sz="1200" b="1" dirty="0">
-                <a:solidFill>
-                  <a:srgbClr val="1A4B8C"/>
-                </a:solidFill>
-                <a:latin typeface="Atkinson Hyperlegible Next" pitchFamily="34" charset="0"/>
-                <a:ea typeface="Atkinson Hyperlegible Next" pitchFamily="34" charset="-122"/>
-                <a:cs typeface="Atkinson Hyperlegible Next" pitchFamily="34" charset="-120"/>
-              </a:rPr>
-              <a:t>VI</a:t>
-            </a:r>
-            <a:endParaRPr lang="en-US" sz="1200" dirty="0"/>
-          </a:p>
-        </p:txBody>
-      </p:sp>
-      <p:sp>
-        <p:nvSpPr>
-          <p:cNvPr id="31" name="Shape 29"/>
+          <p:cNvPr id="25" name="Shape 23"/>
           <p:cNvSpPr/>
           <p:nvPr/>
         </p:nvSpPr>
         <p:spPr>
           <a:xfrm>
-            <a:off x="9135901" y="1993392"/>
-            <a:ext cx="749808" cy="219456"/>
+            <a:off x="8603851" y="1993392"/>
+            <a:ext cx="1281858" cy="219456"/>
           </a:xfrm>
           <a:prstGeom prst="roundRect">
             <a:avLst>
@@ -10646,14 +10467,14 @@
       </p:sp>
       <p:sp>
         <p:nvSpPr>
-          <p:cNvPr id="32" name="Text 30"/>
+          <p:cNvPr id="26" name="Text 24"/>
           <p:cNvSpPr txBox="1"/>
           <p:nvPr/>
         </p:nvSpPr>
         <p:spPr>
           <a:xfrm>
-            <a:off x="9135901" y="1993392"/>
-            <a:ext cx="749808" cy="219456"/>
+            <a:off x="8603851" y="1993392"/>
+            <a:ext cx="1281858" cy="219456"/>
           </a:xfrm>
           <a:prstGeom prst="rect">
             <a:avLst/>
@@ -10677,7 +10498,7 @@
                 <a:ea typeface="Atkinson Hyperlegible Next" pitchFamily="34" charset="-122"/>
                 <a:cs typeface="Atkinson Hyperlegible Next" pitchFamily="34" charset="-120"/>
               </a:rPr>
-              <a:t>działa</a:t>
+              <a:t>zaimplementowane</a:t>
             </a:r>
             <a:endParaRPr lang="en-US" sz="900" dirty="0"/>
           </a:p>
@@ -10685,7 +10506,7 @@
       </p:sp>
       <p:sp>
         <p:nvSpPr>
-          <p:cNvPr id="33" name="Text 31"/>
+          <p:cNvPr id="27" name="Text 25"/>
           <p:cNvSpPr txBox="1"/>
           <p:nvPr/>
         </p:nvSpPr>
@@ -10707,6 +10528,17 @@
             <a:pPr marL="0" indent="0">
               <a:buNone/>
             </a:pPr>
+            <a:r>
+              <a:rPr lang="en-US" sz="1150" b="1" dirty="0">
+                <a:solidFill>
+                  <a:srgbClr val="1A4B8C"/>
+                </a:solidFill>
+                <a:latin typeface="Atkinson Hyperlegible Next" pitchFamily="34" charset="0"/>
+                <a:ea typeface="Atkinson Hyperlegible Next" pitchFamily="34" charset="-122"/>
+                <a:cs typeface="Atkinson Hyperlegible Next" pitchFamily="34" charset="-120"/>
+              </a:rPr>
+              <a:t>VI  </a:t>
+            </a:r>
             <a:r>
               <a:rPr lang="en-US" sz="1150" b="1" dirty="0">
                 <a:solidFill>
@@ -10744,7 +10576,7 @@
       </p:sp>
       <p:sp>
         <p:nvSpPr>
-          <p:cNvPr id="34" name="Shape 32"/>
+          <p:cNvPr id="28" name="Shape 26"/>
           <p:cNvSpPr/>
           <p:nvPr/>
         </p:nvSpPr>
@@ -10771,53 +10603,14 @@
       </p:sp>
       <p:sp>
         <p:nvSpPr>
-          <p:cNvPr id="35" name="Text 33"/>
-          <p:cNvSpPr txBox="1"/>
-          <p:nvPr/>
-        </p:nvSpPr>
-        <p:spPr>
-          <a:xfrm>
-            <a:off x="10196605" y="1993392"/>
-            <a:ext cx="457200" cy="219456"/>
-          </a:xfrm>
-          <a:prstGeom prst="rect">
-            <a:avLst/>
-          </a:prstGeom>
-          <a:noFill/>
-          <a:ln/>
-        </p:spPr>
-        <p:txBody>
-          <a:bodyPr wrap="square" lIns="0" tIns="0" rIns="0" bIns="0" rtlCol="0" anchor="ctr"/>
-          <a:lstStyle/>
-          <a:p>
-            <a:pPr marL="0" indent="0">
-              <a:buNone/>
-            </a:pPr>
-            <a:r>
-              <a:rPr lang="en-US" sz="1200" b="1" dirty="0">
-                <a:solidFill>
-                  <a:srgbClr val="1A4B8C"/>
-                </a:solidFill>
-                <a:latin typeface="Atkinson Hyperlegible Next" pitchFamily="34" charset="0"/>
-                <a:ea typeface="Atkinson Hyperlegible Next" pitchFamily="34" charset="-122"/>
-                <a:cs typeface="Atkinson Hyperlegible Next" pitchFamily="34" charset="-120"/>
-              </a:rPr>
-              <a:t>VII</a:t>
-            </a:r>
-            <a:endParaRPr lang="en-US" sz="1200" dirty="0"/>
-          </a:p>
-        </p:txBody>
-      </p:sp>
-      <p:sp>
-        <p:nvSpPr>
-          <p:cNvPr id="36" name="Shape 34"/>
+          <p:cNvPr id="29" name="Shape 27"/>
           <p:cNvSpPr/>
           <p:nvPr/>
         </p:nvSpPr>
         <p:spPr>
           <a:xfrm>
-            <a:off x="10710367" y="1993392"/>
-            <a:ext cx="749808" cy="219456"/>
+            <a:off x="10178317" y="1993392"/>
+            <a:ext cx="1281858" cy="219456"/>
           </a:xfrm>
           <a:prstGeom prst="roundRect">
             <a:avLst>
@@ -10837,14 +10630,14 @@
       </p:sp>
       <p:sp>
         <p:nvSpPr>
-          <p:cNvPr id="37" name="Text 35"/>
+          <p:cNvPr id="30" name="Text 28"/>
           <p:cNvSpPr txBox="1"/>
           <p:nvPr/>
         </p:nvSpPr>
         <p:spPr>
           <a:xfrm>
-            <a:off x="10710367" y="1993392"/>
-            <a:ext cx="749808" cy="219456"/>
+            <a:off x="10178317" y="1993392"/>
+            <a:ext cx="1281858" cy="219456"/>
           </a:xfrm>
           <a:prstGeom prst="rect">
             <a:avLst/>
@@ -10876,7 +10669,7 @@
       </p:sp>
       <p:sp>
         <p:nvSpPr>
-          <p:cNvPr id="38" name="Text 36"/>
+          <p:cNvPr id="31" name="Text 29"/>
           <p:cNvSpPr txBox="1"/>
           <p:nvPr/>
         </p:nvSpPr>
@@ -10898,6 +10691,17 @@
             <a:pPr marL="0" indent="0">
               <a:buNone/>
             </a:pPr>
+            <a:r>
+              <a:rPr lang="en-US" sz="1150" b="1" dirty="0">
+                <a:solidFill>
+                  <a:srgbClr val="1A4B8C"/>
+                </a:solidFill>
+                <a:latin typeface="Atkinson Hyperlegible Next" pitchFamily="34" charset="0"/>
+                <a:ea typeface="Atkinson Hyperlegible Next" pitchFamily="34" charset="-122"/>
+                <a:cs typeface="Atkinson Hyperlegible Next" pitchFamily="34" charset="-120"/>
+              </a:rPr>
+              <a:t>VII  </a:t>
+            </a:r>
             <a:r>
               <a:rPr lang="en-US" sz="1150" b="1" dirty="0">
                 <a:solidFill>
@@ -10935,7 +10739,7 @@
       </p:sp>
       <p:sp>
         <p:nvSpPr>
-          <p:cNvPr id="39" name="Text 37"/>
+          <p:cNvPr id="32" name="Text 30"/>
           <p:cNvSpPr txBox="1"/>
           <p:nvPr/>
         </p:nvSpPr>
@@ -10974,7 +10778,7 @@
       </p:sp>
       <p:sp>
         <p:nvSpPr>
-          <p:cNvPr id="40" name="Text 38"/>
+          <p:cNvPr id="33" name="Text 31"/>
           <p:cNvSpPr txBox="1"/>
           <p:nvPr/>
         </p:nvSpPr>
@@ -11013,7 +10817,7 @@
       </p:sp>
       <p:sp>
         <p:nvSpPr>
-          <p:cNvPr id="41" name="Text 39"/>
+          <p:cNvPr id="34" name="Text 32"/>
           <p:cNvSpPr txBox="1"/>
           <p:nvPr/>
         </p:nvSpPr>
@@ -11069,7 +10873,7 @@
       </p:sp>
       <p:sp>
         <p:nvSpPr>
-          <p:cNvPr id="42" name="Text 40"/>
+          <p:cNvPr id="35" name="Text 33"/>
           <p:cNvSpPr txBox="1"/>
           <p:nvPr/>
         </p:nvSpPr>
@@ -11125,7 +10929,7 @@
       </p:sp>
       <p:sp>
         <p:nvSpPr>
-          <p:cNvPr id="43" name="Text 41"/>
+          <p:cNvPr id="36" name="Text 34"/>
           <p:cNvSpPr txBox="1"/>
           <p:nvPr/>
         </p:nvSpPr>
@@ -11181,7 +10985,7 @@
       </p:sp>
       <p:sp>
         <p:nvSpPr>
-          <p:cNvPr id="44" name="Text 42"/>
+          <p:cNvPr id="37" name="Text 35"/>
           <p:cNvSpPr txBox="1"/>
           <p:nvPr/>
         </p:nvSpPr>
@@ -11220,7 +11024,7 @@
       </p:sp>
       <p:sp>
         <p:nvSpPr>
-          <p:cNvPr id="45" name="Shape 43"/>
+          <p:cNvPr id="38" name="Shape 36"/>
           <p:cNvSpPr/>
           <p:nvPr/>
         </p:nvSpPr>
@@ -11245,7 +11049,7 @@
       </p:sp>
       <p:sp>
         <p:nvSpPr>
-          <p:cNvPr id="46" name="Text 44"/>
+          <p:cNvPr id="39" name="Text 37"/>
           <p:cNvSpPr txBox="1"/>
           <p:nvPr/>
         </p:nvSpPr>
@@ -11284,7 +11088,7 @@
       </p:sp>
       <p:sp>
         <p:nvSpPr>
-          <p:cNvPr id="47" name="Text 45"/>
+          <p:cNvPr id="40" name="Text 38"/>
           <p:cNvSpPr txBox="1"/>
           <p:nvPr/>
         </p:nvSpPr>
@@ -11389,7 +11193,7 @@
       </p:sp>
       <p:sp>
         <p:nvSpPr>
-          <p:cNvPr id="48" name="Shape 46"/>
+          <p:cNvPr id="41" name="Shape 39"/>
           <p:cNvSpPr/>
           <p:nvPr/>
         </p:nvSpPr>
@@ -11414,7 +11218,7 @@
       </p:sp>
       <p:sp>
         <p:nvSpPr>
-          <p:cNvPr id="49" name="Text 47"/>
+          <p:cNvPr id="42" name="Text 40"/>
           <p:cNvSpPr txBox="1"/>
           <p:nvPr/>
         </p:nvSpPr>
@@ -11453,7 +11257,7 @@
       </p:sp>
       <p:sp>
         <p:nvSpPr>
-          <p:cNvPr id="50" name="Text 48"/>
+          <p:cNvPr id="43" name="Text 41"/>
           <p:cNvSpPr txBox="1"/>
           <p:nvPr/>
         </p:nvSpPr>
@@ -11558,7 +11362,7 @@
       </p:sp>
       <p:sp>
         <p:nvSpPr>
-          <p:cNvPr id="51" name="Shape 49"/>
+          <p:cNvPr id="44" name="Shape 42"/>
           <p:cNvSpPr/>
           <p:nvPr/>
         </p:nvSpPr>
@@ -11583,7 +11387,7 @@
       </p:sp>
       <p:sp>
         <p:nvSpPr>
-          <p:cNvPr id="52" name="Text 50"/>
+          <p:cNvPr id="45" name="Text 43"/>
           <p:cNvSpPr txBox="1"/>
           <p:nvPr/>
         </p:nvSpPr>
@@ -11622,7 +11426,7 @@
       </p:sp>
       <p:sp>
         <p:nvSpPr>
-          <p:cNvPr id="53" name="Text 51"/>
+          <p:cNvPr id="46" name="Text 44"/>
           <p:cNvSpPr txBox="1"/>
           <p:nvPr/>
         </p:nvSpPr>
@@ -11705,7 +11509,7 @@
       </p:sp>
       <p:sp>
         <p:nvSpPr>
-          <p:cNvPr id="54" name="Shape 52"/>
+          <p:cNvPr id="47" name="Shape 45"/>
           <p:cNvSpPr/>
           <p:nvPr/>
         </p:nvSpPr>
@@ -11732,7 +11536,7 @@
       </p:sp>
       <p:sp>
         <p:nvSpPr>
-          <p:cNvPr id="55" name="Text 53"/>
+          <p:cNvPr id="48" name="Text 46"/>
           <p:cNvSpPr txBox="1"/>
           <p:nvPr/>
         </p:nvSpPr>
@@ -11782,7 +11586,7 @@
       </p:sp>
       <p:sp>
         <p:nvSpPr>
-          <p:cNvPr id="56" name="Shape 54"/>
+          <p:cNvPr id="49" name="Shape 47"/>
           <p:cNvSpPr/>
           <p:nvPr/>
         </p:nvSpPr>
@@ -11809,14 +11613,320 @@
       </p:sp>
       <p:sp>
         <p:nvSpPr>
+          <p:cNvPr id="50" name="Text 48"/>
+          <p:cNvSpPr txBox="1"/>
+          <p:nvPr/>
+        </p:nvSpPr>
+        <p:spPr>
+          <a:xfrm>
+            <a:off x="6080760" y="5385816"/>
+            <a:ext cx="5287975" cy="274320"/>
+          </a:xfrm>
+          <a:prstGeom prst="rect">
+            <a:avLst/>
+          </a:prstGeom>
+          <a:noFill/>
+          <a:ln/>
+        </p:spPr>
+        <p:txBody>
+          <a:bodyPr wrap="square" lIns="0" tIns="0" rIns="0" bIns="0" rtlCol="0" anchor="ctr"/>
+          <a:lstStyle/>
+          <a:p>
+            <a:pPr marL="0" indent="0">
+              <a:buNone/>
+            </a:pPr>
+            <a:r>
+              <a:rPr lang="en-US" sz="1300" b="1" dirty="0">
+                <a:solidFill>
+                  <a:srgbClr val="1A4B8C"/>
+                </a:solidFill>
+                <a:latin typeface="Atkinson Hyperlegible Next" pitchFamily="34" charset="0"/>
+                <a:ea typeface="Atkinson Hyperlegible Next" pitchFamily="34" charset="-122"/>
+                <a:cs typeface="Atkinson Hyperlegible Next" pitchFamily="34" charset="-120"/>
+              </a:rPr>
+              <a:t>Około 55 USD miesięcznie plus 8 USD za 1000 dróg</a:t>
+            </a:r>
+            <a:endParaRPr lang="en-US" sz="1300" dirty="0"/>
+          </a:p>
+        </p:txBody>
+      </p:sp>
+      <p:sp>
+        <p:nvSpPr>
+          <p:cNvPr id="51" name="Text 49"/>
+          <p:cNvSpPr txBox="1"/>
+          <p:nvPr/>
+        </p:nvSpPr>
+        <p:spPr>
+          <a:xfrm>
+            <a:off x="6080760" y="5660136"/>
+            <a:ext cx="4282135" cy="164592"/>
+          </a:xfrm>
+          <a:prstGeom prst="rect">
+            <a:avLst/>
+          </a:prstGeom>
+          <a:noFill/>
+          <a:ln/>
+        </p:spPr>
+        <p:txBody>
+          <a:bodyPr wrap="square" lIns="0" tIns="0" rIns="0" bIns="0" rtlCol="0" anchor="ctr"/>
+          <a:lstStyle/>
+          <a:p>
+            <a:pPr marL="0" indent="0">
+              <a:buNone/>
+            </a:pPr>
+            <a:r>
+              <a:rPr lang="en-US" sz="1050" b="1" dirty="0">
+                <a:solidFill>
+                  <a:srgbClr val="14171A"/>
+                </a:solidFill>
+                <a:latin typeface="Atkinson Hyperlegible Next" pitchFamily="34" charset="0"/>
+                <a:ea typeface="Atkinson Hyperlegible Next" pitchFamily="34" charset="-122"/>
+                <a:cs typeface="Atkinson Hyperlegible Next" pitchFamily="34" charset="-120"/>
+              </a:rPr>
+              <a:t>Serwer  </a:t>
+            </a:r>
+            <a:r>
+              <a:rPr lang="en-US" sz="1050" dirty="0">
+                <a:solidFill>
+                  <a:srgbClr val="454D57"/>
+                </a:solidFill>
+                <a:latin typeface="Atkinson Hyperlegible Next" pitchFamily="34" charset="0"/>
+                <a:ea typeface="Atkinson Hyperlegible Next" pitchFamily="34" charset="-122"/>
+                <a:cs typeface="Atkinson Hyperlegible Next" pitchFamily="34" charset="-120"/>
+              </a:rPr>
+              <a:t>aplikacja + polski model wyszukiwania, 4 GB</a:t>
+            </a:r>
+            <a:endParaRPr lang="en-US" sz="1050" dirty="0"/>
+          </a:p>
+        </p:txBody>
+      </p:sp>
+      <p:sp>
+        <p:nvSpPr>
+          <p:cNvPr id="52" name="Text 50"/>
+          <p:cNvSpPr txBox="1"/>
+          <p:nvPr/>
+        </p:nvSpPr>
+        <p:spPr>
+          <a:xfrm>
+            <a:off x="10317175" y="5660136"/>
+            <a:ext cx="1051560" cy="164592"/>
+          </a:xfrm>
+          <a:prstGeom prst="rect">
+            <a:avLst/>
+          </a:prstGeom>
+          <a:noFill/>
+          <a:ln/>
+        </p:spPr>
+        <p:txBody>
+          <a:bodyPr wrap="square" lIns="0" tIns="0" rIns="0" bIns="0" rtlCol="0" anchor="ctr"/>
+          <a:lstStyle/>
+          <a:p>
+            <a:pPr marL="0" indent="0" algn="r">
+              <a:buNone/>
+            </a:pPr>
+            <a:r>
+              <a:rPr lang="en-US" sz="1050" b="1" dirty="0">
+                <a:solidFill>
+                  <a:srgbClr val="14171A"/>
+                </a:solidFill>
+                <a:latin typeface="Atkinson Hyperlegible Next" pitchFamily="34" charset="0"/>
+                <a:ea typeface="Atkinson Hyperlegible Next" pitchFamily="34" charset="-122"/>
+                <a:cs typeface="Atkinson Hyperlegible Next" pitchFamily="34" charset="-120"/>
+              </a:rPr>
+              <a:t>24 USD / mies.</a:t>
+            </a:r>
+            <a:endParaRPr lang="en-US" sz="1050" dirty="0"/>
+          </a:p>
+        </p:txBody>
+      </p:sp>
+      <p:sp>
+        <p:nvSpPr>
+          <p:cNvPr id="53" name="Text 51"/>
+          <p:cNvSpPr txBox="1"/>
+          <p:nvPr/>
+        </p:nvSpPr>
+        <p:spPr>
+          <a:xfrm>
+            <a:off x="6080760" y="5824728"/>
+            <a:ext cx="4282135" cy="164592"/>
+          </a:xfrm>
+          <a:prstGeom prst="rect">
+            <a:avLst/>
+          </a:prstGeom>
+          <a:noFill/>
+          <a:ln/>
+        </p:spPr>
+        <p:txBody>
+          <a:bodyPr wrap="square" lIns="0" tIns="0" rIns="0" bIns="0" rtlCol="0" anchor="ctr"/>
+          <a:lstStyle/>
+          <a:p>
+            <a:pPr marL="0" indent="0">
+              <a:buNone/>
+            </a:pPr>
+            <a:r>
+              <a:rPr lang="en-US" sz="1050" b="1" dirty="0">
+                <a:solidFill>
+                  <a:srgbClr val="14171A"/>
+                </a:solidFill>
+                <a:latin typeface="Atkinson Hyperlegible Next" pitchFamily="34" charset="0"/>
+                <a:ea typeface="Atkinson Hyperlegible Next" pitchFamily="34" charset="-122"/>
+                <a:cs typeface="Atkinson Hyperlegible Next" pitchFamily="34" charset="-120"/>
+              </a:rPr>
+              <a:t>Baza danych  </a:t>
+            </a:r>
+            <a:r>
+              <a:rPr lang="en-US" sz="1050" dirty="0">
+                <a:solidFill>
+                  <a:srgbClr val="454D57"/>
+                </a:solidFill>
+                <a:latin typeface="Atkinson Hyperlegible Next" pitchFamily="34" charset="0"/>
+                <a:ea typeface="Atkinson Hyperlegible Next" pitchFamily="34" charset="-122"/>
+                <a:cs typeface="Atkinson Hyperlegible Next" pitchFamily="34" charset="-120"/>
+              </a:rPr>
+              <a:t>PostgreSQL + pgvector, RDS 2 GB</a:t>
+            </a:r>
+            <a:endParaRPr lang="en-US" sz="1050" dirty="0"/>
+          </a:p>
+        </p:txBody>
+      </p:sp>
+      <p:sp>
+        <p:nvSpPr>
+          <p:cNvPr id="54" name="Text 52"/>
+          <p:cNvSpPr txBox="1"/>
+          <p:nvPr/>
+        </p:nvSpPr>
+        <p:spPr>
+          <a:xfrm>
+            <a:off x="10317175" y="5824728"/>
+            <a:ext cx="1051560" cy="164592"/>
+          </a:xfrm>
+          <a:prstGeom prst="rect">
+            <a:avLst/>
+          </a:prstGeom>
+          <a:noFill/>
+          <a:ln/>
+        </p:spPr>
+        <p:txBody>
+          <a:bodyPr wrap="square" lIns="0" tIns="0" rIns="0" bIns="0" rtlCol="0" anchor="ctr"/>
+          <a:lstStyle/>
+          <a:p>
+            <a:pPr marL="0" indent="0" algn="r">
+              <a:buNone/>
+            </a:pPr>
+            <a:r>
+              <a:rPr lang="en-US" sz="1050" b="1" dirty="0">
+                <a:solidFill>
+                  <a:srgbClr val="14171A"/>
+                </a:solidFill>
+                <a:latin typeface="Atkinson Hyperlegible Next" pitchFamily="34" charset="0"/>
+                <a:ea typeface="Atkinson Hyperlegible Next" pitchFamily="34" charset="-122"/>
+                <a:cs typeface="Atkinson Hyperlegible Next" pitchFamily="34" charset="-120"/>
+              </a:rPr>
+              <a:t>30 USD / mies.</a:t>
+            </a:r>
+            <a:endParaRPr lang="en-US" sz="1050" dirty="0"/>
+          </a:p>
+        </p:txBody>
+      </p:sp>
+      <p:sp>
+        <p:nvSpPr>
+          <p:cNvPr id="55" name="Text 53"/>
+          <p:cNvSpPr txBox="1"/>
+          <p:nvPr/>
+        </p:nvSpPr>
+        <p:spPr>
+          <a:xfrm>
+            <a:off x="6080760" y="5989320"/>
+            <a:ext cx="4282135" cy="164592"/>
+          </a:xfrm>
+          <a:prstGeom prst="rect">
+            <a:avLst/>
+          </a:prstGeom>
+          <a:noFill/>
+          <a:ln/>
+        </p:spPr>
+        <p:txBody>
+          <a:bodyPr wrap="square" lIns="0" tIns="0" rIns="0" bIns="0" rtlCol="0" anchor="ctr"/>
+          <a:lstStyle/>
+          <a:p>
+            <a:pPr marL="0" indent="0">
+              <a:buNone/>
+            </a:pPr>
+            <a:r>
+              <a:rPr lang="en-US" sz="1050" b="1" dirty="0">
+                <a:solidFill>
+                  <a:srgbClr val="14171A"/>
+                </a:solidFill>
+                <a:latin typeface="Atkinson Hyperlegible Next" pitchFamily="34" charset="0"/>
+                <a:ea typeface="Atkinson Hyperlegible Next" pitchFamily="34" charset="-122"/>
+                <a:cs typeface="Atkinson Hyperlegible Next" pitchFamily="34" charset="-120"/>
+              </a:rPr>
+              <a:t>Zapytanie do modelu  </a:t>
+            </a:r>
+            <a:r>
+              <a:rPr lang="en-US" sz="1050" dirty="0">
+                <a:solidFill>
+                  <a:srgbClr val="454D57"/>
+                </a:solidFill>
+                <a:latin typeface="Atkinson Hyperlegible Next" pitchFamily="34" charset="0"/>
+                <a:ea typeface="Atkinson Hyperlegible Next" pitchFamily="34" charset="-122"/>
+                <a:cs typeface="Atkinson Hyperlegible Next" pitchFamily="34" charset="-120"/>
+              </a:rPr>
+              <a:t>Bielik 11B na Hugging Face, ~5 tys. tokenów</a:t>
+            </a:r>
+            <a:endParaRPr lang="en-US" sz="1050" dirty="0"/>
+          </a:p>
+        </p:txBody>
+      </p:sp>
+      <p:sp>
+        <p:nvSpPr>
+          <p:cNvPr id="56" name="Text 54"/>
+          <p:cNvSpPr txBox="1"/>
+          <p:nvPr/>
+        </p:nvSpPr>
+        <p:spPr>
+          <a:xfrm>
+            <a:off x="10317175" y="5989320"/>
+            <a:ext cx="1051560" cy="164592"/>
+          </a:xfrm>
+          <a:prstGeom prst="rect">
+            <a:avLst/>
+          </a:prstGeom>
+          <a:noFill/>
+          <a:ln/>
+        </p:spPr>
+        <p:txBody>
+          <a:bodyPr wrap="square" lIns="0" tIns="0" rIns="0" bIns="0" rtlCol="0" anchor="ctr"/>
+          <a:lstStyle/>
+          <a:p>
+            <a:pPr marL="0" indent="0" algn="r">
+              <a:buNone/>
+            </a:pPr>
+            <a:r>
+              <a:rPr lang="en-US" sz="1050" b="1" dirty="0">
+                <a:solidFill>
+                  <a:srgbClr val="14171A"/>
+                </a:solidFill>
+                <a:latin typeface="Atkinson Hyperlegible Next" pitchFamily="34" charset="0"/>
+                <a:ea typeface="Atkinson Hyperlegible Next" pitchFamily="34" charset="-122"/>
+                <a:cs typeface="Atkinson Hyperlegible Next" pitchFamily="34" charset="-120"/>
+              </a:rPr>
+              <a:t>0,002 USD</a:t>
+            </a:r>
+            <a:endParaRPr lang="en-US" sz="1050" dirty="0"/>
+          </a:p>
+        </p:txBody>
+      </p:sp>
+      <p:sp>
+        <p:nvSpPr>
           <p:cNvPr id="57" name="Text 55"/>
           <p:cNvSpPr txBox="1"/>
           <p:nvPr/>
         </p:nvSpPr>
         <p:spPr>
           <a:xfrm>
-            <a:off x="6080760" y="5385816"/>
-            <a:ext cx="5287975" cy="274320"/>
+            <a:off x="6080760" y="6153912"/>
+            <a:ext cx="4282135" cy="164592"/>
           </a:xfrm>
           <a:prstGeom prst="rect">
             <a:avLst/>
@@ -11832,17 +11942,28 @@
               <a:buNone/>
             </a:pPr>
             <a:r>
-              <a:rPr lang="en-US" sz="1300" b="1" dirty="0">
-                <a:solidFill>
-                  <a:srgbClr val="1A4B8C"/>
-                </a:solidFill>
-                <a:latin typeface="Atkinson Hyperlegible Next" pitchFamily="34" charset="0"/>
-                <a:ea typeface="Atkinson Hyperlegible Next" pitchFamily="34" charset="-122"/>
-                <a:cs typeface="Atkinson Hyperlegible Next" pitchFamily="34" charset="-120"/>
-              </a:rPr>
-              <a:t>Około 55 USD miesięcznie plus 8 USD za 1000 dróg</a:t>
-            </a:r>
-            <a:endParaRPr lang="en-US" sz="1300" dirty="0"/>
+              <a:rPr lang="en-US" sz="1050" b="1" dirty="0">
+                <a:solidFill>
+                  <a:srgbClr val="14171A"/>
+                </a:solidFill>
+                <a:latin typeface="Atkinson Hyperlegible Next" pitchFamily="34" charset="0"/>
+                <a:ea typeface="Atkinson Hyperlegible Next" pitchFamily="34" charset="-122"/>
+                <a:cs typeface="Atkinson Hyperlegible Next" pitchFamily="34" charset="-120"/>
+              </a:rPr>
+              <a:t>Droga  </a:t>
+            </a:r>
+            <a:r>
+              <a:rPr lang="en-US" sz="1050" dirty="0">
+                <a:solidFill>
+                  <a:srgbClr val="454D57"/>
+                </a:solidFill>
+                <a:latin typeface="Atkinson Hyperlegible Next" pitchFamily="34" charset="0"/>
+                <a:ea typeface="Atkinson Hyperlegible Next" pitchFamily="34" charset="-122"/>
+                <a:cs typeface="Atkinson Hyperlegible Next" pitchFamily="34" charset="-120"/>
+              </a:rPr>
+              <a:t>4 zapytania, ~21 tys. tokenów</a:t>
+            </a:r>
+            <a:endParaRPr lang="en-US" sz="1050" dirty="0"/>
           </a:p>
         </p:txBody>
       </p:sp>
@@ -11854,8 +11975,8 @@
         </p:nvSpPr>
         <p:spPr>
           <a:xfrm>
-            <a:off x="6080760" y="5660136"/>
-            <a:ext cx="4282135" cy="164592"/>
+            <a:off x="10317175" y="6153912"/>
+            <a:ext cx="1051560" cy="164592"/>
           </a:xfrm>
           <a:prstGeom prst="rect">
             <a:avLst/>
@@ -11867,7 +11988,7 @@
           <a:bodyPr wrap="square" lIns="0" tIns="0" rIns="0" bIns="0" rtlCol="0" anchor="ctr"/>
           <a:lstStyle/>
           <a:p>
-            <a:pPr marL="0" indent="0">
+            <a:pPr marL="0" indent="0" algn="r">
               <a:buNone/>
             </a:pPr>
             <a:r>
@@ -11879,18 +12000,7 @@
                 <a:ea typeface="Atkinson Hyperlegible Next" pitchFamily="34" charset="-122"/>
                 <a:cs typeface="Atkinson Hyperlegible Next" pitchFamily="34" charset="-120"/>
               </a:rPr>
-              <a:t>Serwer  </a:t>
-            </a:r>
-            <a:r>
-              <a:rPr lang="en-US" sz="1050" dirty="0">
-                <a:solidFill>
-                  <a:srgbClr val="454D57"/>
-                </a:solidFill>
-                <a:latin typeface="Atkinson Hyperlegible Next" pitchFamily="34" charset="0"/>
-                <a:ea typeface="Atkinson Hyperlegible Next" pitchFamily="34" charset="-122"/>
-                <a:cs typeface="Atkinson Hyperlegible Next" pitchFamily="34" charset="-120"/>
-              </a:rPr>
-              <a:t>aplikacja + polski model wyszukiwania, 4 GB</a:t>
+              <a:t>0,008 USD</a:t>
             </a:r>
             <a:endParaRPr lang="en-US" sz="1050" dirty="0"/>
           </a:p>
@@ -11899,312 +12009,6 @@
       <p:sp>
         <p:nvSpPr>
           <p:cNvPr id="59" name="Text 57"/>
-          <p:cNvSpPr txBox="1"/>
-          <p:nvPr/>
-        </p:nvSpPr>
-        <p:spPr>
-          <a:xfrm>
-            <a:off x="10317175" y="5660136"/>
-            <a:ext cx="1051560" cy="164592"/>
-          </a:xfrm>
-          <a:prstGeom prst="rect">
-            <a:avLst/>
-          </a:prstGeom>
-          <a:noFill/>
-          <a:ln/>
-        </p:spPr>
-        <p:txBody>
-          <a:bodyPr wrap="square" lIns="0" tIns="0" rIns="0" bIns="0" rtlCol="0" anchor="ctr"/>
-          <a:lstStyle/>
-          <a:p>
-            <a:pPr marL="0" indent="0" algn="r">
-              <a:buNone/>
-            </a:pPr>
-            <a:r>
-              <a:rPr lang="en-US" sz="1050" b="1" dirty="0">
-                <a:solidFill>
-                  <a:srgbClr val="14171A"/>
-                </a:solidFill>
-                <a:latin typeface="Atkinson Hyperlegible Next" pitchFamily="34" charset="0"/>
-                <a:ea typeface="Atkinson Hyperlegible Next" pitchFamily="34" charset="-122"/>
-                <a:cs typeface="Atkinson Hyperlegible Next" pitchFamily="34" charset="-120"/>
-              </a:rPr>
-              <a:t>24 USD / mies.</a:t>
-            </a:r>
-            <a:endParaRPr lang="en-US" sz="1050" dirty="0"/>
-          </a:p>
-        </p:txBody>
-      </p:sp>
-      <p:sp>
-        <p:nvSpPr>
-          <p:cNvPr id="60" name="Text 58"/>
-          <p:cNvSpPr txBox="1"/>
-          <p:nvPr/>
-        </p:nvSpPr>
-        <p:spPr>
-          <a:xfrm>
-            <a:off x="6080760" y="5824728"/>
-            <a:ext cx="4282135" cy="164592"/>
-          </a:xfrm>
-          <a:prstGeom prst="rect">
-            <a:avLst/>
-          </a:prstGeom>
-          <a:noFill/>
-          <a:ln/>
-        </p:spPr>
-        <p:txBody>
-          <a:bodyPr wrap="square" lIns="0" tIns="0" rIns="0" bIns="0" rtlCol="0" anchor="ctr"/>
-          <a:lstStyle/>
-          <a:p>
-            <a:pPr marL="0" indent="0">
-              <a:buNone/>
-            </a:pPr>
-            <a:r>
-              <a:rPr lang="en-US" sz="1050" b="1" dirty="0">
-                <a:solidFill>
-                  <a:srgbClr val="14171A"/>
-                </a:solidFill>
-                <a:latin typeface="Atkinson Hyperlegible Next" pitchFamily="34" charset="0"/>
-                <a:ea typeface="Atkinson Hyperlegible Next" pitchFamily="34" charset="-122"/>
-                <a:cs typeface="Atkinson Hyperlegible Next" pitchFamily="34" charset="-120"/>
-              </a:rPr>
-              <a:t>Baza danych  </a:t>
-            </a:r>
-            <a:r>
-              <a:rPr lang="en-US" sz="1050" dirty="0">
-                <a:solidFill>
-                  <a:srgbClr val="454D57"/>
-                </a:solidFill>
-                <a:latin typeface="Atkinson Hyperlegible Next" pitchFamily="34" charset="0"/>
-                <a:ea typeface="Atkinson Hyperlegible Next" pitchFamily="34" charset="-122"/>
-                <a:cs typeface="Atkinson Hyperlegible Next" pitchFamily="34" charset="-120"/>
-              </a:rPr>
-              <a:t>PostgreSQL + pgvector, RDS 2 GB</a:t>
-            </a:r>
-            <a:endParaRPr lang="en-US" sz="1050" dirty="0"/>
-          </a:p>
-        </p:txBody>
-      </p:sp>
-      <p:sp>
-        <p:nvSpPr>
-          <p:cNvPr id="61" name="Text 59"/>
-          <p:cNvSpPr txBox="1"/>
-          <p:nvPr/>
-        </p:nvSpPr>
-        <p:spPr>
-          <a:xfrm>
-            <a:off x="10317175" y="5824728"/>
-            <a:ext cx="1051560" cy="164592"/>
-          </a:xfrm>
-          <a:prstGeom prst="rect">
-            <a:avLst/>
-          </a:prstGeom>
-          <a:noFill/>
-          <a:ln/>
-        </p:spPr>
-        <p:txBody>
-          <a:bodyPr wrap="square" lIns="0" tIns="0" rIns="0" bIns="0" rtlCol="0" anchor="ctr"/>
-          <a:lstStyle/>
-          <a:p>
-            <a:pPr marL="0" indent="0" algn="r">
-              <a:buNone/>
-            </a:pPr>
-            <a:r>
-              <a:rPr lang="en-US" sz="1050" b="1" dirty="0">
-                <a:solidFill>
-                  <a:srgbClr val="14171A"/>
-                </a:solidFill>
-                <a:latin typeface="Atkinson Hyperlegible Next" pitchFamily="34" charset="0"/>
-                <a:ea typeface="Atkinson Hyperlegible Next" pitchFamily="34" charset="-122"/>
-                <a:cs typeface="Atkinson Hyperlegible Next" pitchFamily="34" charset="-120"/>
-              </a:rPr>
-              <a:t>30 USD / mies.</a:t>
-            </a:r>
-            <a:endParaRPr lang="en-US" sz="1050" dirty="0"/>
-          </a:p>
-        </p:txBody>
-      </p:sp>
-      <p:sp>
-        <p:nvSpPr>
-          <p:cNvPr id="62" name="Text 60"/>
-          <p:cNvSpPr txBox="1"/>
-          <p:nvPr/>
-        </p:nvSpPr>
-        <p:spPr>
-          <a:xfrm>
-            <a:off x="6080760" y="5989320"/>
-            <a:ext cx="4282135" cy="164592"/>
-          </a:xfrm>
-          <a:prstGeom prst="rect">
-            <a:avLst/>
-          </a:prstGeom>
-          <a:noFill/>
-          <a:ln/>
-        </p:spPr>
-        <p:txBody>
-          <a:bodyPr wrap="square" lIns="0" tIns="0" rIns="0" bIns="0" rtlCol="0" anchor="ctr"/>
-          <a:lstStyle/>
-          <a:p>
-            <a:pPr marL="0" indent="0">
-              <a:buNone/>
-            </a:pPr>
-            <a:r>
-              <a:rPr lang="en-US" sz="1050" b="1" dirty="0">
-                <a:solidFill>
-                  <a:srgbClr val="14171A"/>
-                </a:solidFill>
-                <a:latin typeface="Atkinson Hyperlegible Next" pitchFamily="34" charset="0"/>
-                <a:ea typeface="Atkinson Hyperlegible Next" pitchFamily="34" charset="-122"/>
-                <a:cs typeface="Atkinson Hyperlegible Next" pitchFamily="34" charset="-120"/>
-              </a:rPr>
-              <a:t>Zapytanie do modelu  </a:t>
-            </a:r>
-            <a:r>
-              <a:rPr lang="en-US" sz="1050" dirty="0">
-                <a:solidFill>
-                  <a:srgbClr val="454D57"/>
-                </a:solidFill>
-                <a:latin typeface="Atkinson Hyperlegible Next" pitchFamily="34" charset="0"/>
-                <a:ea typeface="Atkinson Hyperlegible Next" pitchFamily="34" charset="-122"/>
-                <a:cs typeface="Atkinson Hyperlegible Next" pitchFamily="34" charset="-120"/>
-              </a:rPr>
-              <a:t>Bielik 11B na Hugging Face, ~5 tys. tokenów</a:t>
-            </a:r>
-            <a:endParaRPr lang="en-US" sz="1050" dirty="0"/>
-          </a:p>
-        </p:txBody>
-      </p:sp>
-      <p:sp>
-        <p:nvSpPr>
-          <p:cNvPr id="63" name="Text 61"/>
-          <p:cNvSpPr txBox="1"/>
-          <p:nvPr/>
-        </p:nvSpPr>
-        <p:spPr>
-          <a:xfrm>
-            <a:off x="10317175" y="5989320"/>
-            <a:ext cx="1051560" cy="164592"/>
-          </a:xfrm>
-          <a:prstGeom prst="rect">
-            <a:avLst/>
-          </a:prstGeom>
-          <a:noFill/>
-          <a:ln/>
-        </p:spPr>
-        <p:txBody>
-          <a:bodyPr wrap="square" lIns="0" tIns="0" rIns="0" bIns="0" rtlCol="0" anchor="ctr"/>
-          <a:lstStyle/>
-          <a:p>
-            <a:pPr marL="0" indent="0" algn="r">
-              <a:buNone/>
-            </a:pPr>
-            <a:r>
-              <a:rPr lang="en-US" sz="1050" b="1" dirty="0">
-                <a:solidFill>
-                  <a:srgbClr val="14171A"/>
-                </a:solidFill>
-                <a:latin typeface="Atkinson Hyperlegible Next" pitchFamily="34" charset="0"/>
-                <a:ea typeface="Atkinson Hyperlegible Next" pitchFamily="34" charset="-122"/>
-                <a:cs typeface="Atkinson Hyperlegible Next" pitchFamily="34" charset="-120"/>
-              </a:rPr>
-              <a:t>0,002 USD</a:t>
-            </a:r>
-            <a:endParaRPr lang="en-US" sz="1050" dirty="0"/>
-          </a:p>
-        </p:txBody>
-      </p:sp>
-      <p:sp>
-        <p:nvSpPr>
-          <p:cNvPr id="64" name="Text 62"/>
-          <p:cNvSpPr txBox="1"/>
-          <p:nvPr/>
-        </p:nvSpPr>
-        <p:spPr>
-          <a:xfrm>
-            <a:off x="6080760" y="6153912"/>
-            <a:ext cx="4282135" cy="164592"/>
-          </a:xfrm>
-          <a:prstGeom prst="rect">
-            <a:avLst/>
-          </a:prstGeom>
-          <a:noFill/>
-          <a:ln/>
-        </p:spPr>
-        <p:txBody>
-          <a:bodyPr wrap="square" lIns="0" tIns="0" rIns="0" bIns="0" rtlCol="0" anchor="ctr"/>
-          <a:lstStyle/>
-          <a:p>
-            <a:pPr marL="0" indent="0">
-              <a:buNone/>
-            </a:pPr>
-            <a:r>
-              <a:rPr lang="en-US" sz="1050" b="1" dirty="0">
-                <a:solidFill>
-                  <a:srgbClr val="14171A"/>
-                </a:solidFill>
-                <a:latin typeface="Atkinson Hyperlegible Next" pitchFamily="34" charset="0"/>
-                <a:ea typeface="Atkinson Hyperlegible Next" pitchFamily="34" charset="-122"/>
-                <a:cs typeface="Atkinson Hyperlegible Next" pitchFamily="34" charset="-120"/>
-              </a:rPr>
-              <a:t>Droga  </a:t>
-            </a:r>
-            <a:r>
-              <a:rPr lang="en-US" sz="1050" dirty="0">
-                <a:solidFill>
-                  <a:srgbClr val="454D57"/>
-                </a:solidFill>
-                <a:latin typeface="Atkinson Hyperlegible Next" pitchFamily="34" charset="0"/>
-                <a:ea typeface="Atkinson Hyperlegible Next" pitchFamily="34" charset="-122"/>
-                <a:cs typeface="Atkinson Hyperlegible Next" pitchFamily="34" charset="-120"/>
-              </a:rPr>
-              <a:t>4 zapytania, ~21 tys. tokenów</a:t>
-            </a:r>
-            <a:endParaRPr lang="en-US" sz="1050" dirty="0"/>
-          </a:p>
-        </p:txBody>
-      </p:sp>
-      <p:sp>
-        <p:nvSpPr>
-          <p:cNvPr id="65" name="Text 63"/>
-          <p:cNvSpPr txBox="1"/>
-          <p:nvPr/>
-        </p:nvSpPr>
-        <p:spPr>
-          <a:xfrm>
-            <a:off x="10317175" y="6153912"/>
-            <a:ext cx="1051560" cy="164592"/>
-          </a:xfrm>
-          <a:prstGeom prst="rect">
-            <a:avLst/>
-          </a:prstGeom>
-          <a:noFill/>
-          <a:ln/>
-        </p:spPr>
-        <p:txBody>
-          <a:bodyPr wrap="square" lIns="0" tIns="0" rIns="0" bIns="0" rtlCol="0" anchor="ctr"/>
-          <a:lstStyle/>
-          <a:p>
-            <a:pPr marL="0" indent="0" algn="r">
-              <a:buNone/>
-            </a:pPr>
-            <a:r>
-              <a:rPr lang="en-US" sz="1050" b="1" dirty="0">
-                <a:solidFill>
-                  <a:srgbClr val="14171A"/>
-                </a:solidFill>
-                <a:latin typeface="Atkinson Hyperlegible Next" pitchFamily="34" charset="0"/>
-                <a:ea typeface="Atkinson Hyperlegible Next" pitchFamily="34" charset="-122"/>
-                <a:cs typeface="Atkinson Hyperlegible Next" pitchFamily="34" charset="-120"/>
-              </a:rPr>
-              <a:t>0,008 USD</a:t>
-            </a:r>
-            <a:endParaRPr lang="en-US" sz="1050" dirty="0"/>
-          </a:p>
-        </p:txBody>
-      </p:sp>
-      <p:sp>
-        <p:nvSpPr>
-          <p:cNvPr id="66" name="Text 64"/>
           <p:cNvSpPr txBox="1"/>
           <p:nvPr/>
         </p:nvSpPr>

</xml_diff>

<commit_message>
Update submission and presentation
</commit_message>
<xml_diff>
--- a/docs/presentation/presentation.pptx
+++ b/docs/presentation/presentation.pptx
@@ -158,7 +158,7 @@
     </p:spTree>
     <p:extLst>
       <p:ext uri="{BB962C8B-B14F-4D97-AF65-F5344CB8AC3E}">
-        <p14:creationId xmlns:p14="http://schemas.microsoft.com/office/powerpoint/2010/main" val="486834089"/>
+        <p14:creationId xmlns:p14="http://schemas.microsoft.com/office/powerpoint/2010/main" val="2029574140"/>
       </p:ext>
     </p:extLst>
   </p:cSld>
@@ -304,7 +304,7 @@
           <a:p>
             <a:r>
               <a:rPr lang="en-US" dirty="0"/>
-              <a:t>HubMI.pl to nazwa, którą ROPS w Krakowie nadał cyfrowemu sercu planowanego Małopolskiego Hubu Innowacji Społecznych. Partner sam opisał zadanie tak: nie kolejny katalog, tylko narzędzie, które łączy problem z rozwiązaniem, wiedzą i ludźmi, a gdy rozwiązania jeszcze nie ma, pomaga znaleźć drogę do jego stworzenia. Zbudowaliśmy działający prototyp: stronę dla osób zgłaszających potrzeby i panel dla ROPS. Kolejne slajdy pokazują moduł po module, jak prototyp realizuje wyzwanie. Na telefonie widać prawdziwą drogę z prototypu.</a:t>
+              <a:t>HubMI.pl to nazwa, którą ROPS w Krakowie nadał cyfrowemu sercu planowanego Małopolskiego Hubu Innowacji Społecznych. Partner sam opisał zadanie tak: nie kolejny katalog, tylko narzędzie, które łączy problem z rozwiązaniem, wiedzą i ludźmi, a gdy rozwiązania jeszcze nie ma, pomaga znaleźć drogę do jego stworzenia. Zbudowaliśmy aplikację HubMI.pl: stronę dla osób zgłaszających potrzeby i panel dla ROPS. Kolejne slajdy pokazują moduł po module, jak HubMI realizuje wyzwanie. Na telefonie widać prawdziwą drogę z aplikacji.</a:t>
             </a:r>
           </a:p>
         </p:txBody>
@@ -391,7 +391,7 @@
           <a:p>
             <a:r>
               <a:rPr lang="en-US" dirty="0"/>
-              <a:t>Moduł pierwszy, obowiązkowy: matchmaking społeczny. To prawdziwa droga z prototypu dla przypadku testowego P01: samotni seniorzy w wiejskiej gminie Laskowa. Składa się z czterech części. Rozwiązania: sprawdzone innowacje, każda z uzasadnieniem opartym na cytatach ze źródła i z informacją, czego wymaga. Wiedza: poradniki i modele usług ROPS. Ludzie: autorzy, opiekun kategorii w ROPS i osoby, które zgłosiły gotowość do pomocy. Ścieżka wdrożenia: programy, z których można to sfinansować, z kwotami, terminami i kolejnymi krokami. To nie lista wyników wyszukiwania, tylko odpowiedź na pytanie, co zrobić dalej.</a:t>
+              <a:t>Moduł pierwszy, obowiązkowy: matchmaking społeczny. To prawdziwa droga z aplikacji dla przypadku testowego P01: samotni seniorzy w wiejskiej gminie Laskowa. Składa się z czterech części. Rozwiązania: sprawdzone innowacje, każda z uzasadnieniem opartym na cytatach ze źródła i z informacją, czego wymaga. Wiedza: instrukcje wdrożenia i modele usług ROPS. Ludzie: eksperci, czyli autorzy innowacji i realizatorzy w pobliżu, opiekun kategorii w ROPS i wolontariusze, którzy zgłosili gotowość do pomocy. Ścieżka wdrożenia: programy, z których można to sfinansować, z kwotami, terminami i kolejnymi krokami. To nie lista wyników wyszukiwania, tylko odpowiedź na pytanie, co zrobić dalej.</a:t>
             </a:r>
           </a:p>
         </p:txBody>
@@ -478,7 +478,7 @@
           <a:p>
             <a:r>
               <a:rPr lang="en-US" dirty="0"/>
-              <a:t>Drugi element modułu pierwszego: podobne przypadki. Pod rozwiązaniami widać potrzeby z banku potrzeb i fiszki pomysłów podobne do tej, ale tylko te, na których publikację zgodził się autor i które zaakceptował ROPS. Ktoś zapyta: czy to nie zwykła wyszukiwarka albo czatbot do katalogu? Nie. Wyszukiwarka daje linki, czatbot z RAG pisze zgrabny akapit, a oba narzędzia odpowiadają na każde pytanie. HubMI układa drogę według reguł, na podstawie opracowanych danych: kwoty i terminy pochodzą z trzydziestu ścieżek, do których model nie ma dostępu; model tylko wybiera i wyjaśnia, a program sprawdza każde odwołanie i każdy cytat. I potrafi powiedzieć „nie”: przez tegoroczną suszę w studniach w gminie Dobra zabrakło wody, nic w katalogach nie pasuje, a narzędzie mówi to wprost i proponuje wpis do banku potrzeb; na jego podstawie powstaje fiszka dla inkubatora. Trafność sprawdzamy na przypadkach testowych: we wszystkich siedmiu, dla których istnieje sprawdzone rozwiązanie, właściwa innowacja jest wśród trzech proponowanych.</a:t>
+              <a:t>Drugi element modułu pierwszego: podobne przypadki. Pod rozwiązaniami widać potrzeby z banku potrzeb i fiszki pomysłów podobne do tej, ale tylko te, na których publikację zgodził się autor i które zaakceptował ROPS. HubMI to więcej niż wyszukiwarka i czatbot: prowadzi od odpowiedzi do działania. Wyszukiwarka daje listę linków, a gdy nic nie pasuje, zwraca luźno powiązane wyniki. Czatbot z RAG odpowiada na podstawie źródeł, ale odpowiada zawsze, nawet gdy nic nie pasuje. HubMI daje dopasowane rozwiązania, wiedzę, kontakty i kroki wdrożenia. Model dobiera rozwiązania i uzasadnia dopasowanie, a system dodatkowo sprawdza każde odwołanie i każdy cytat. Kwoty i terminy pobieramy bezpośrednio z trzydziestu opracowanych ścieżek finansowania, a nie z tekstu modelu. Wyniki są przejrzyste także wtedy, gdy rozwiązania brak: przez tegoroczną suszę w studniach w gminie Dobra zabrakło wody, nic w katalogach nie pasuje, więc narzędzie informuje o braku dopasowania i nie rekomenduje rozwiązań. Proponuje za to wpis do banku potrzeb, a na jego podstawie powstaje fiszka dla inkubatora. Trafność sprawdzamy na przypadkach testowych: we wszystkich siedmiu przypadkach z dostępnym rozwiązaniem właściwa innowacja jest wśród trzech rekomendacji, a w dziewięciu z dziesięciu narzędzie poprawnie rozpoznaje, czy można zaproponować pełne, częściowe lub żadne dopasowanie.</a:t>
             </a:r>
           </a:p>
         </p:txBody>
@@ -913,7 +913,7 @@
           <a:p>
             <a:r>
               <a:rPr lang="en-US" dirty="0"/>
-              <a:t>Zadanie wymaga koncepcji, a nie tylko oprogramowania. To, co widzieliście, jest już zaimplementowane: droga dla osób zgłaszających potrzeby, a obok fiszka pomysłu, tester innowacji, rozmowy z ROPS i mentorami oraz tablica partnerstw. Z siedmiu modułów wyzwania pięć jest zaimplementowanych w całości, a dwa – częściowo. Zasobnik wiedzy celowo nie jest kolejnym katalogiem, bo partner wyraźnie tego nie chce: wiedza jest częścią drogi, z linkami do wszystkich materiałów, dokumentów i filmów. Każdy wpis trafia do panelu ROPS: decyzję podejmuje pracownik, a system odnotowuje ją z jego nazwiskiem; autor pomysłu widzi odpowiedź na stronie swojej fiszki. Plan rozwoju dotyczy ludzi wokół narzędzia: trzech ról, które mogą pełnić trzy osoby albo jedna – opiekun kategorii, czyli osoba kontaktowa w każdej drodze, redaktor katalogu i koordynator banku potrzeb. Usługa domknie trzy cykle: potrzeba staje się wdrożeniem; potrzeba bez rozwiązania staje się tematem naboru do inkubatora, a potem nową innowacją; sprawdzona innowacja trafia tam, gdzie jest potrzebna. Utrzymanie jest tanie: jeden serwer 4 GB dla aplikacji i polskiego modelu wyszukiwania to 24 dolary miesięcznie na AWS Lightsail; w wersji docelowej PostgreSQL z pgvector na RDS, około 30 dolarów miesięcznie (prototyp zapisuje wpisy w jednym pliku). Jedno zapytanie do Bielika przez Hugging Face to około pięciu tysięcy tokenów po 40 centów za milion, czyli jedna piąta centa; cała droga to cztery zapytania, łącznie poniżej jednego centa.</a:t>
+              <a:t>Zadanie wymaga koncepcji, a nie tylko oprogramowania. To, co widzieliście, jest już zaimplementowane: droga dla osób zgłaszających potrzeby, a obok fiszka pomysłu, tester innowacji, rozmowy z ROPS i mentorami oraz tablica partnerstw. Z siedmiu modułów wyzwania pięć jest zaimplementowanych w całości, a dwa – częściowo. Zasobnik wiedzy celowo nie jest kolejnym katalogiem, bo partner wyraźnie tego nie chce: wiedza jest częścią drogi, z linkami do wszystkich materiałów, dokumentów i filmów. Każdy wpis trafia do panelu ROPS: decyzję podejmuje pracownik, a system odnotowuje ją z jego nazwiskiem; autor pomysłu widzi odpowiedź na stronie swojej fiszki. Plan rozwoju dotyczy ludzi wokół narzędzia: trzech ról, które mogą pełnić trzy osoby albo jedna – opiekun kategorii, czyli osoba kontaktowa w każdej drodze, redaktor katalogu i koordynator banku potrzeb. Usługa domknie trzy cykle: potrzeba staje się wdrożeniem; potrzeba bez rozwiązania staje się tematem naboru do inkubatora, a potem nową innowacją; sprawdzona innowacja trafia tam, gdzie jest potrzebna. Utrzymanie jest tanie: jeden serwer 4 GB dla aplikacji i polskiego modelu wyszukiwania to 24 dolary miesięcznie na AWS Lightsail; w wersji docelowej PostgreSQL z pgvector na RDS, około 30 dolarów miesięcznie (obecna wersja zapisuje wpisy w jednym pliku). Jedno zapytanie do Bielika przez Hugging Face to około pięciu tysięcy tokenów po 40 centów za milion, czyli jedna piąta centa; cała droga to cztery zapytania, łącznie poniżej jednego centa.</a:t>
             </a:r>
           </a:p>
         </p:txBody>
@@ -1899,7 +1899,7 @@
                 <a:ea typeface="Atkinson Hyperlegible Next" pitchFamily="34" charset="-122"/>
                 <a:cs typeface="Atkinson Hyperlegible Next" pitchFamily="34" charset="-120"/>
               </a:rPr>
-              <a:t>Wymaganie: system „proponuje gotowe rozwiązania/innowacje społeczne”.</a:t>
+              <a:t>Wymaganie: system „proponuje gotowe rozwiązania”.</a:t>
             </a:r>
             <a:r>
               <a:rPr lang="en-US" sz="1600" dirty="0">
@@ -1910,7 +1910,7 @@
                 <a:ea typeface="Atkinson Hyperlegible Next" pitchFamily="34" charset="-122"/>
                 <a:cs typeface="Atkinson Hyperlegible Next" pitchFamily="34" charset="-120"/>
               </a:rPr>
-              <a:t>  Prawdziwa droga z prototypu</a:t>
+              <a:t>  Proponujemy rozwiązania sprawdzone w praktyce</a:t>
             </a:r>
             <a:endParaRPr lang="en-US" sz="3200" dirty="0"/>
           </a:p>
@@ -2166,7 +2166,7 @@
                 <a:ea typeface="Atkinson Hyperlegible Next" pitchFamily="34" charset="-122"/>
                 <a:cs typeface="Atkinson Hyperlegible Next" pitchFamily="34" charset="-120"/>
               </a:rPr>
-              <a:t>Każdy cytat porównujemy z opisem w katalogu. Tekst wygenerowany przez AI jest oznaczony.</a:t>
+              <a:t>Opis potrzeby dopasowujemy do rozwiązań z katalogu. Odpowiedzi AI oparte są na materiałach źródłowych.</a:t>
             </a:r>
             <a:endParaRPr lang="en-US" sz="1200" dirty="0"/>
           </a:p>
@@ -2477,7 +2477,7 @@
                 <a:ea typeface="Atkinson Hyperlegible Next" pitchFamily="34" charset="-122"/>
                 <a:cs typeface="Atkinson Hyperlegible Next" pitchFamily="34" charset="-120"/>
               </a:rPr>
-              <a:t>poradniki i modele usług</a:t>
+              <a:t>instrukcje wdrożenia i modele usług</a:t>
             </a:r>
             <a:endParaRPr lang="en-US" sz="1400" dirty="0"/>
           </a:p>
@@ -2674,7 +2674,7 @@
                 <a:ea typeface="Atkinson Hyperlegible Next" pitchFamily="34" charset="-122"/>
                 <a:cs typeface="Atkinson Hyperlegible Next" pitchFamily="34" charset="-120"/>
               </a:rPr>
-              <a:t>autorzy, opiekun, chętni do pomocy</a:t>
+              <a:t>eksperci, opiekunowie, wolontariusze</a:t>
             </a:r>
             <a:endParaRPr lang="en-US" sz="1400" dirty="0"/>
           </a:p>
@@ -3170,7 +3170,7 @@
                 <a:ea typeface="Atkinson Hyperlegible Next" pitchFamily="34" charset="-122"/>
                 <a:cs typeface="Atkinson Hyperlegible Next" pitchFamily="34" charset="-120"/>
               </a:rPr>
-              <a:t>Podobne przypadki i jasne „nie”</a:t>
+              <a:t>Podobne przypadki – przejrzyste wyniki</a:t>
             </a:r>
             <a:endParaRPr lang="en-US" sz="3200" dirty="0"/>
           </a:p>
@@ -3201,7 +3201,7 @@
                 <a:ea typeface="Atkinson Hyperlegible Next" pitchFamily="34" charset="-122"/>
                 <a:cs typeface="Atkinson Hyperlegible Next" pitchFamily="34" charset="-120"/>
               </a:rPr>
-              <a:t>  Ani wyszukiwarka, ani czatbot do dokumentów</a:t>
+              <a:t>  Więcej niż wyszukiwarka i czatbot – od odpowiedzi do działania</a:t>
             </a:r>
             <a:endParaRPr lang="en-US" sz="3200" dirty="0"/>
           </a:p>
@@ -3223,7 +3223,7 @@
         </p:nvGraphicFramePr>
         <p:xfrm>
           <a:off x="640080" y="1691640"/>
-          <a:ext cx="5989320" cy="914400"/>
+          <a:ext cx="6400800" cy="914400"/>
         </p:xfrm>
         <a:graphic>
           <a:graphicData uri="http://schemas.openxmlformats.org/drawingml/2006/table">
@@ -3237,7 +3237,7 @@
                     </a:ext>
                   </a:extLst>
                 </a:gridCol>
-                <a:gridCol w="1188720">
+                <a:gridCol w="1280160">
                   <a:extLst>
                     <a:ext uri="{9D8B030D-6E8A-4147-A177-3AD203B41FA5}">
                       <a16:colId xmlns:a16="http://schemas.microsoft.com/office/drawing/2014/main" val="20001"/>
@@ -3251,7 +3251,7 @@
                     </a:ext>
                   </a:extLst>
                 </a:gridCol>
-                <a:gridCol w="2194560">
+                <a:gridCol w="2514600">
                   <a:extLst>
                     <a:ext uri="{9D8B030D-6E8A-4147-A177-3AD203B41FA5}">
                       <a16:colId xmlns:a16="http://schemas.microsoft.com/office/drawing/2014/main" val="20003"/>
@@ -3675,7 +3675,7 @@
                           <a:ea typeface="Atkinson Hyperlegible Next" pitchFamily="34" charset="-122"/>
                           <a:cs typeface="Atkinson Hyperlegible Next" pitchFamily="34" charset="-120"/>
                         </a:rPr>
-                        <a:t>Zgrabny akapit</a:t>
+                        <a:t>Odpowiedź na podstawie źródeł</a:t>
                       </a:r>
                       <a:endParaRPr lang="en-US" sz="1100" dirty="0">
                         <a:latin typeface="Atkinson Hyperlegible Next" charset="0"/>
@@ -3740,7 +3740,7 @@
                           <a:ea typeface="Atkinson Hyperlegible Next" pitchFamily="34" charset="-122"/>
                           <a:cs typeface="Atkinson Hyperlegible Next" pitchFamily="34" charset="-120"/>
                         </a:rPr>
-                        <a:t>Drogę: rozwiązania, wiedzę, ludzi, finansowanie i kolejne kroki</a:t>
+                        <a:t>Dopasowane rozwiązania, wiedzę, kontakty i kroki wdrożenia</a:t>
                       </a:r>
                       <a:endParaRPr lang="en-US" sz="1100" dirty="0">
                         <a:latin typeface="Atkinson Hyperlegible Next" charset="0"/>
@@ -3880,7 +3880,7 @@
                           <a:ea typeface="Atkinson Hyperlegible Next" pitchFamily="34" charset="-122"/>
                           <a:cs typeface="Atkinson Hyperlegible Next" pitchFamily="34" charset="-120"/>
                         </a:rPr>
-                        <a:t>Mimo to daje listę</a:t>
+                        <a:t>Zwraca luźno powiązane wyniki</a:t>
                       </a:r>
                       <a:endParaRPr lang="en-US" sz="1100" dirty="0">
                         <a:latin typeface="Atkinson Hyperlegible Next" charset="0"/>
@@ -4010,7 +4010,7 @@
                           <a:ea typeface="Atkinson Hyperlegible Next" pitchFamily="34" charset="-122"/>
                           <a:cs typeface="Atkinson Hyperlegible Next" pitchFamily="34" charset="-120"/>
                         </a:rPr>
-                        <a:t>Mówi to wprost: przy wyniku poniżej 45/100 nie proponuje drogi</a:t>
+                        <a:t>Informuje o braku dopasowania – przy wyniku poniżej 45/100 nie rekomenduje rozwiązań</a:t>
                       </a:r>
                       <a:endParaRPr lang="en-US" sz="1100" dirty="0">
                         <a:latin typeface="Atkinson Hyperlegible Next" charset="0"/>
@@ -4150,7 +4150,7 @@
                           <a:ea typeface="Atkinson Hyperlegible Next" pitchFamily="34" charset="-122"/>
                           <a:cs typeface="Atkinson Hyperlegible Next" pitchFamily="34" charset="-120"/>
                         </a:rPr>
-                        <a:t>Ze stron internetowych</a:t>
+                        <a:t>Do znalezienia w źródłach</a:t>
                       </a:r>
                       <a:endParaRPr lang="en-US" sz="1100" dirty="0">
                         <a:latin typeface="Atkinson Hyperlegible Next" charset="0"/>
@@ -4215,7 +4215,7 @@
                           <a:ea typeface="Atkinson Hyperlegible Next" pitchFamily="34" charset="-122"/>
                           <a:cs typeface="Atkinson Hyperlegible Next" pitchFamily="34" charset="-120"/>
                         </a:rPr>
-                        <a:t>Pisze je model</a:t>
+                        <a:t>Opracowywane przez model</a:t>
                       </a:r>
                       <a:endParaRPr lang="en-US" sz="1100" dirty="0">
                         <a:latin typeface="Atkinson Hyperlegible Next" charset="0"/>
@@ -4280,7 +4280,7 @@
                           <a:ea typeface="Atkinson Hyperlegible Next" pitchFamily="34" charset="-122"/>
                           <a:cs typeface="Atkinson Hyperlegible Next" pitchFamily="34" charset="-120"/>
                         </a:rPr>
-                        <a:t>Z 30 udokumentowanych ścieżek; model nie ma do nich dostępu</a:t>
+                        <a:t>Pobierane bezpośrednio z opracowanych ścieżek finansowania</a:t>
                       </a:r>
                       <a:endParaRPr lang="en-US" sz="1100" dirty="0">
                         <a:latin typeface="Atkinson Hyperlegible Next" charset="0"/>
@@ -4420,7 +4420,7 @@
                           <a:ea typeface="Atkinson Hyperlegible Next" pitchFamily="34" charset="-122"/>
                           <a:cs typeface="Atkinson Hyperlegible Next" pitchFamily="34" charset="-120"/>
                         </a:rPr>
-                        <a:t>Szereguje strony</a:t>
+                        <a:t>Porządkuje wyniki</a:t>
                       </a:r>
                       <a:endParaRPr lang="en-US" sz="1100" dirty="0">
                         <a:latin typeface="Atkinson Hyperlegible Next" charset="0"/>
@@ -4550,7 +4550,7 @@
                           <a:ea typeface="Atkinson Hyperlegible Next" pitchFamily="34" charset="-122"/>
                           <a:cs typeface="Atkinson Hyperlegible Next" pitchFamily="34" charset="-120"/>
                         </a:rPr>
-                        <a:t>Wybiera i wyjaśnia; program sprawdza każde odwołanie i cytat</a:t>
+                        <a:t>Dobiera rozwiązania i uzasadnia dopasowanie. Odwołania i cytaty są dodatkowo sprawdzane przez system</a:t>
                       </a:r>
                       <a:endParaRPr lang="en-US" sz="1100" dirty="0">
                         <a:latin typeface="Atkinson Hyperlegible Next" charset="0"/>
@@ -4619,12 +4619,12 @@
         </p:nvSpPr>
         <p:spPr>
           <a:xfrm>
-            <a:off x="640080" y="4572000"/>
-            <a:ext cx="5989320" cy="1783080"/>
+            <a:off x="640080" y="4800600"/>
+            <a:ext cx="6400800" cy="1554480"/>
           </a:xfrm>
           <a:prstGeom prst="roundRect">
             <a:avLst>
-              <a:gd name="adj" fmla="val 5128"/>
+              <a:gd name="adj" fmla="val 5882"/>
             </a:avLst>
           </a:prstGeom>
           <a:solidFill>
@@ -4646,8 +4646,8 @@
         </p:nvSpPr>
         <p:spPr>
           <a:xfrm>
-            <a:off x="868680" y="4709160"/>
-            <a:ext cx="5532120" cy="237744"/>
+            <a:off x="868680" y="4937760"/>
+            <a:ext cx="5943600" cy="237744"/>
           </a:xfrm>
           <a:prstGeom prst="rect">
             <a:avLst/>
@@ -4685,8 +4685,8 @@
         </p:nvSpPr>
         <p:spPr>
           <a:xfrm>
-            <a:off x="868680" y="5029200"/>
-            <a:ext cx="2628900" cy="1234440"/>
+            <a:off x="868680" y="5257800"/>
+            <a:ext cx="2834640" cy="1005840"/>
           </a:xfrm>
           <a:prstGeom prst="rect">
             <a:avLst/>
@@ -4730,7 +4730,7 @@
                 <a:ea typeface="Atkinson Hyperlegible Next" pitchFamily="34" charset="-122"/>
                 <a:cs typeface="Atkinson Hyperlegible Next" pitchFamily="34" charset="-120"/>
               </a:rPr>
-              <a:t>przypadków, dla których istnieje sprawdzone rozwiązanie: właściwa innowacja jest wśród trzech proponowanych</a:t>
+              <a:t>Właściwe rozwiązanie wśród trzech rekomendacji – w przypadkach z dostępnym rozwiązaniem</a:t>
             </a:r>
             <a:endParaRPr lang="en-US" sz="3000" dirty="0"/>
           </a:p>
@@ -4744,8 +4744,8 @@
         </p:nvSpPr>
         <p:spPr>
           <a:xfrm>
-            <a:off x="3771900" y="5029200"/>
-            <a:ext cx="2628900" cy="1234440"/>
+            <a:off x="3977640" y="5257800"/>
+            <a:ext cx="2834640" cy="1005840"/>
           </a:xfrm>
           <a:prstGeom prst="rect">
             <a:avLst/>
@@ -4789,7 +4789,7 @@
                 <a:ea typeface="Atkinson Hyperlegible Next" pitchFamily="34" charset="-122"/>
                 <a:cs typeface="Atkinson Hyperlegible Next" pitchFamily="34" charset="-120"/>
               </a:rPr>
-              <a:t>przypadków: narzędzie trafnie rozpoznaje, czy jest pełna droga, częściowa, czy żadna</a:t>
+              <a:t>Poprawne rozpoznanie, czy można zaproponować pełne, częściowe lub żadne dopasowanie</a:t>
             </a:r>
             <a:endParaRPr lang="en-US" sz="3000" dirty="0"/>
           </a:p>
@@ -4803,7 +4803,7 @@
         </p:nvSpPr>
         <p:spPr>
           <a:xfrm>
-            <a:off x="7599776" y="1691640"/>
+            <a:off x="7805516" y="1691640"/>
             <a:ext cx="3392943" cy="1615889"/>
           </a:xfrm>
           <a:prstGeom prst="rect">
@@ -4843,7 +4843,7 @@
         </p:blipFill>
         <p:spPr>
           <a:xfrm>
-            <a:off x="7599776" y="1691640"/>
+            <a:off x="7805516" y="1691640"/>
             <a:ext cx="3392943" cy="1615889"/>
           </a:xfrm>
           <a:prstGeom prst="rect">
@@ -4859,7 +4859,7 @@
         </p:nvSpPr>
         <p:spPr>
           <a:xfrm>
-            <a:off x="7599776" y="1691640"/>
+            <a:off x="7805516" y="1691640"/>
             <a:ext cx="3392943" cy="1615889"/>
           </a:xfrm>
           <a:prstGeom prst="rect">
@@ -4886,7 +4886,7 @@
         </p:nvSpPr>
         <p:spPr>
           <a:xfrm>
-            <a:off x="7599776" y="3380681"/>
+            <a:off x="7805516" y="3380681"/>
             <a:ext cx="3392943" cy="457200"/>
           </a:xfrm>
           <a:prstGeom prst="rect">
@@ -4925,7 +4925,7 @@
         </p:nvSpPr>
         <p:spPr>
           <a:xfrm>
-            <a:off x="7599776" y="4112201"/>
+            <a:off x="7805516" y="4112201"/>
             <a:ext cx="3392943" cy="1712527"/>
           </a:xfrm>
           <a:prstGeom prst="rect">
@@ -4965,7 +4965,7 @@
         </p:blipFill>
         <p:spPr>
           <a:xfrm>
-            <a:off x="7599776" y="4112201"/>
+            <a:off x="7805516" y="4112201"/>
             <a:ext cx="3392943" cy="1712527"/>
           </a:xfrm>
           <a:prstGeom prst="rect">
@@ -4981,7 +4981,7 @@
         </p:nvSpPr>
         <p:spPr>
           <a:xfrm>
-            <a:off x="7599776" y="4112201"/>
+            <a:off x="7805516" y="4112201"/>
             <a:ext cx="3392943" cy="1712527"/>
           </a:xfrm>
           <a:prstGeom prst="rect">
@@ -5008,7 +5008,7 @@
         </p:nvSpPr>
         <p:spPr>
           <a:xfrm>
-            <a:off x="7599776" y="5897880"/>
+            <a:off x="7805516" y="5897880"/>
             <a:ext cx="3392943" cy="457200"/>
           </a:xfrm>
           <a:prstGeom prst="rect">

</xml_diff>